<commit_message>
deck: 10 slides + per-slide speaker notes (CN/EN), run & compliance slide
</commit_message>
<xml_diff>
--- a/submit/TeaWindow_Pitch_EN.pptx
+++ b/submit/TeaWindow_Pitch_EN.pptx
@@ -6,14 +6,15 @@
   </p:sldMasterIdLst>
   <p:sldIdLst>
     <p:sldId id="256" r:id="rId7"/>
-    <p:sldId id="257" r:id="rId8"/>
-    <p:sldId id="258" r:id="rId9"/>
-    <p:sldId id="259" r:id="rId10"/>
-    <p:sldId id="260" r:id="rId11"/>
-    <p:sldId id="261" r:id="rId12"/>
-    <p:sldId id="262" r:id="rId13"/>
-    <p:sldId id="263" r:id="rId14"/>
-    <p:sldId id="264" r:id="rId15"/>
+    <p:sldId id="257" r:id="rId9"/>
+    <p:sldId id="258" r:id="rId10"/>
+    <p:sldId id="259" r:id="rId11"/>
+    <p:sldId id="260" r:id="rId12"/>
+    <p:sldId id="261" r:id="rId13"/>
+    <p:sldId id="262" r:id="rId14"/>
+    <p:sldId id="263" r:id="rId15"/>
+    <p:sldId id="264" r:id="rId16"/>
+    <p:sldId id="265" r:id="rId17"/>
   </p:sldIdLst>
   <p:sldSz cx="12191695" cy="6858000" type="screen4x3"/>
   <p:notesSz cx="6858000" cy="9144000"/>
@@ -113,6 +114,1056 @@
     </a:lvl9pPr>
   </p:defaultTextStyle>
 </p:presentation>
+</file>
+
+<file path=ppt/notesMasters/notesMaster1.xml><?xml version="1.0" encoding="utf-8"?>
+<p:notesMaster xmlns:a="http://schemas.openxmlformats.org/drawingml/2006/main" xmlns:p="http://schemas.openxmlformats.org/presentationml/2006/main" xmlns:r="http://schemas.openxmlformats.org/officeDocument/2006/relationships">
+  <p:cSld>
+    <p:bg>
+      <p:bgRef idx="1001">
+        <a:schemeClr val="bg1"/>
+      </p:bgRef>
+    </p:bg>
+    <p:spTree>
+      <p:nvGrpSpPr>
+        <p:cNvPr id="1" name=""/>
+        <p:cNvGrpSpPr/>
+        <p:nvPr/>
+      </p:nvGrpSpPr>
+      <p:grpSpPr>
+        <a:xfrm>
+          <a:off x="0" y="0"/>
+          <a:ext cx="0" cy="0"/>
+          <a:chOff x="0" y="0"/>
+          <a:chExt cx="0" cy="0"/>
+        </a:xfrm>
+      </p:grpSpPr>
+      <p:sp>
+        <p:nvSpPr>
+          <p:cNvPr id="2" name="Header Placeholder 1"/>
+          <p:cNvSpPr>
+            <a:spLocks noGrp="1"/>
+          </p:cNvSpPr>
+          <p:nvPr>
+            <p:ph type="hdr" sz="quarter"/>
+          </p:nvPr>
+        </p:nvSpPr>
+        <p:spPr>
+          <a:xfrm>
+            <a:off x="0" y="0"/>
+            <a:ext cx="2971800" cy="457200"/>
+          </a:xfrm>
+          <a:prstGeom prst="rect">
+            <a:avLst/>
+          </a:prstGeom>
+        </p:spPr>
+        <p:txBody>
+          <a:bodyPr vert="horz" lIns="91440" tIns="45720" rIns="91440" bIns="45720" rtlCol="0"/>
+          <a:lstStyle>
+            <a:lvl1pPr algn="l">
+              <a:defRPr sz="1200"/>
+            </a:lvl1pPr>
+          </a:lstStyle>
+          <a:p>
+            <a:endParaRPr lang="en-US"/>
+          </a:p>
+        </p:txBody>
+      </p:sp>
+      <p:sp>
+        <p:nvSpPr>
+          <p:cNvPr id="3" name="Date Placeholder 2"/>
+          <p:cNvSpPr>
+            <a:spLocks noGrp="1"/>
+          </p:cNvSpPr>
+          <p:nvPr>
+            <p:ph type="dt" idx="1"/>
+          </p:nvPr>
+        </p:nvSpPr>
+        <p:spPr>
+          <a:xfrm>
+            <a:off x="3884613" y="0"/>
+            <a:ext cx="2971800" cy="457200"/>
+          </a:xfrm>
+          <a:prstGeom prst="rect">
+            <a:avLst/>
+          </a:prstGeom>
+        </p:spPr>
+        <p:txBody>
+          <a:bodyPr vert="horz" lIns="91440" tIns="45720" rIns="91440" bIns="45720" rtlCol="0"/>
+          <a:lstStyle>
+            <a:lvl1pPr algn="r">
+              <a:defRPr sz="1200"/>
+            </a:lvl1pPr>
+          </a:lstStyle>
+          <a:p>
+            <a:fld id="{0F89C1C7-3DCD-1040-A9CF-14679D8B5DDD}" type="datetimeFigureOut">
+              <a:rPr lang="en-US" smtClean="0"/>
+              <a:t>10/17/16</a:t>
+            </a:fld>
+            <a:endParaRPr lang="en-US"/>
+          </a:p>
+        </p:txBody>
+      </p:sp>
+      <p:sp>
+        <p:nvSpPr>
+          <p:cNvPr id="4" name="Slide Image Placeholder 3"/>
+          <p:cNvSpPr>
+            <a:spLocks noGrp="1" noRot="1" noChangeAspect="1"/>
+          </p:cNvSpPr>
+          <p:nvPr>
+            <p:ph type="sldImg" idx="2"/>
+          </p:nvPr>
+        </p:nvSpPr>
+        <p:spPr>
+          <a:xfrm>
+            <a:off x="1143000" y="685800"/>
+            <a:ext cx="4572000" cy="3429000"/>
+          </a:xfrm>
+          <a:prstGeom prst="rect">
+            <a:avLst/>
+          </a:prstGeom>
+          <a:noFill/>
+          <a:ln w="12700">
+            <a:solidFill>
+              <a:prstClr val="black"/>
+            </a:solidFill>
+          </a:ln>
+        </p:spPr>
+        <p:txBody>
+          <a:bodyPr vert="horz" lIns="91440" tIns="45720" rIns="91440" bIns="45720" rtlCol="0" anchor="ctr"/>
+          <a:lstStyle/>
+          <a:p>
+            <a:endParaRPr lang="en-US"/>
+          </a:p>
+        </p:txBody>
+      </p:sp>
+      <p:sp>
+        <p:nvSpPr>
+          <p:cNvPr id="5" name="Notes Placeholder 4"/>
+          <p:cNvSpPr>
+            <a:spLocks noGrp="1"/>
+          </p:cNvSpPr>
+          <p:nvPr>
+            <p:ph type="body" sz="quarter" idx="3"/>
+          </p:nvPr>
+        </p:nvSpPr>
+        <p:spPr>
+          <a:xfrm>
+            <a:off x="685800" y="4343400"/>
+            <a:ext cx="5486400" cy="4114800"/>
+          </a:xfrm>
+          <a:prstGeom prst="rect">
+            <a:avLst/>
+          </a:prstGeom>
+        </p:spPr>
+        <p:txBody>
+          <a:bodyPr vert="horz" lIns="91440" tIns="45720" rIns="91440" bIns="45720" rtlCol="0"/>
+          <a:lstStyle/>
+          <a:p>
+            <a:pPr lvl="0"/>
+            <a:r>
+              <a:rPr lang="en-US" smtClean="0"/>
+              <a:t>Click to edit Master text styles</a:t>
+            </a:r>
+          </a:p>
+          <a:p>
+            <a:pPr lvl="1"/>
+            <a:r>
+              <a:rPr lang="en-US" smtClean="0"/>
+              <a:t>Second level</a:t>
+            </a:r>
+          </a:p>
+          <a:p>
+            <a:pPr lvl="2"/>
+            <a:r>
+              <a:rPr lang="en-US" smtClean="0"/>
+              <a:t>Third level</a:t>
+            </a:r>
+          </a:p>
+          <a:p>
+            <a:pPr lvl="3"/>
+            <a:r>
+              <a:rPr lang="en-US" smtClean="0"/>
+              <a:t>Fourth level</a:t>
+            </a:r>
+          </a:p>
+          <a:p>
+            <a:pPr lvl="4"/>
+            <a:r>
+              <a:rPr lang="en-US" smtClean="0"/>
+              <a:t>Fifth level</a:t>
+            </a:r>
+            <a:endParaRPr lang="en-US"/>
+          </a:p>
+        </p:txBody>
+      </p:sp>
+      <p:sp>
+        <p:nvSpPr>
+          <p:cNvPr id="6" name="Footer Placeholder 5"/>
+          <p:cNvSpPr>
+            <a:spLocks noGrp="1"/>
+          </p:cNvSpPr>
+          <p:nvPr>
+            <p:ph type="ftr" sz="quarter" idx="4"/>
+          </p:nvPr>
+        </p:nvSpPr>
+        <p:spPr>
+          <a:xfrm>
+            <a:off x="0" y="8685213"/>
+            <a:ext cx="2971800" cy="457200"/>
+          </a:xfrm>
+          <a:prstGeom prst="rect">
+            <a:avLst/>
+          </a:prstGeom>
+        </p:spPr>
+        <p:txBody>
+          <a:bodyPr vert="horz" lIns="91440" tIns="45720" rIns="91440" bIns="45720" rtlCol="0" anchor="b"/>
+          <a:lstStyle>
+            <a:lvl1pPr algn="l">
+              <a:defRPr sz="1200"/>
+            </a:lvl1pPr>
+          </a:lstStyle>
+          <a:p>
+            <a:endParaRPr lang="en-US"/>
+          </a:p>
+        </p:txBody>
+      </p:sp>
+      <p:sp>
+        <p:nvSpPr>
+          <p:cNvPr id="7" name="Slide Number Placeholder 6"/>
+          <p:cNvSpPr>
+            <a:spLocks noGrp="1"/>
+          </p:cNvSpPr>
+          <p:nvPr>
+            <p:ph type="sldNum" sz="quarter" idx="5"/>
+          </p:nvPr>
+        </p:nvSpPr>
+        <p:spPr>
+          <a:xfrm>
+            <a:off x="3884613" y="8685213"/>
+            <a:ext cx="2971800" cy="457200"/>
+          </a:xfrm>
+          <a:prstGeom prst="rect">
+            <a:avLst/>
+          </a:prstGeom>
+        </p:spPr>
+        <p:txBody>
+          <a:bodyPr vert="horz" lIns="91440" tIns="45720" rIns="91440" bIns="45720" rtlCol="0" anchor="b"/>
+          <a:lstStyle>
+            <a:lvl1pPr algn="r">
+              <a:defRPr sz="1200"/>
+            </a:lvl1pPr>
+          </a:lstStyle>
+          <a:p>
+            <a:fld id="{BB5E49A5-4136-284D-997B-48E1D791AD67}" type="slidenum">
+              <a:rPr lang="en-US" smtClean="0"/>
+              <a:t>‹#›</a:t>
+            </a:fld>
+            <a:endParaRPr lang="en-US"/>
+          </a:p>
+        </p:txBody>
+      </p:sp>
+    </p:spTree>
+    <p:extLst>
+      <p:ext uri="{BB962C8B-B14F-4D97-AF65-F5344CB8AC3E}">
+        <p14:creationId xmlns:p14="http://schemas.microsoft.com/office/powerpoint/2010/main" val="2623252185"/>
+      </p:ext>
+    </p:extLst>
+  </p:cSld>
+  <p:clrMap bg1="lt1" tx1="dk1" bg2="lt2" tx2="dk2" accent1="accent1" accent2="accent2" accent3="accent3" accent4="accent4" accent5="accent5" accent6="accent6" hlink="hlink" folHlink="folHlink"/>
+  <p:notesStyle>
+    <a:lvl1pPr marL="0" algn="l" defTabSz="457200" rtl="0" eaLnBrk="1" latinLnBrk="0" hangingPunct="1">
+      <a:defRPr sz="1200" kern="1200">
+        <a:solidFill>
+          <a:schemeClr val="tx1"/>
+        </a:solidFill>
+        <a:latin typeface="+mn-lt"/>
+        <a:ea typeface="+mn-ea"/>
+        <a:cs typeface="+mn-cs"/>
+      </a:defRPr>
+    </a:lvl1pPr>
+    <a:lvl2pPr marL="457200" algn="l" defTabSz="457200" rtl="0" eaLnBrk="1" latinLnBrk="0" hangingPunct="1">
+      <a:defRPr sz="1200" kern="1200">
+        <a:solidFill>
+          <a:schemeClr val="tx1"/>
+        </a:solidFill>
+        <a:latin typeface="+mn-lt"/>
+        <a:ea typeface="+mn-ea"/>
+        <a:cs typeface="+mn-cs"/>
+      </a:defRPr>
+    </a:lvl2pPr>
+    <a:lvl3pPr marL="914400" algn="l" defTabSz="457200" rtl="0" eaLnBrk="1" latinLnBrk="0" hangingPunct="1">
+      <a:defRPr sz="1200" kern="1200">
+        <a:solidFill>
+          <a:schemeClr val="tx1"/>
+        </a:solidFill>
+        <a:latin typeface="+mn-lt"/>
+        <a:ea typeface="+mn-ea"/>
+        <a:cs typeface="+mn-cs"/>
+      </a:defRPr>
+    </a:lvl3pPr>
+    <a:lvl4pPr marL="1371600" algn="l" defTabSz="457200" rtl="0" eaLnBrk="1" latinLnBrk="0" hangingPunct="1">
+      <a:defRPr sz="1200" kern="1200">
+        <a:solidFill>
+          <a:schemeClr val="tx1"/>
+        </a:solidFill>
+        <a:latin typeface="+mn-lt"/>
+        <a:ea typeface="+mn-ea"/>
+        <a:cs typeface="+mn-cs"/>
+      </a:defRPr>
+    </a:lvl4pPr>
+    <a:lvl5pPr marL="1828800" algn="l" defTabSz="457200" rtl="0" eaLnBrk="1" latinLnBrk="0" hangingPunct="1">
+      <a:defRPr sz="1200" kern="1200">
+        <a:solidFill>
+          <a:schemeClr val="tx1"/>
+        </a:solidFill>
+        <a:latin typeface="+mn-lt"/>
+        <a:ea typeface="+mn-ea"/>
+        <a:cs typeface="+mn-cs"/>
+      </a:defRPr>
+    </a:lvl5pPr>
+    <a:lvl6pPr marL="2286000" algn="l" defTabSz="457200" rtl="0" eaLnBrk="1" latinLnBrk="0" hangingPunct="1">
+      <a:defRPr sz="1200" kern="1200">
+        <a:solidFill>
+          <a:schemeClr val="tx1"/>
+        </a:solidFill>
+        <a:latin typeface="+mn-lt"/>
+        <a:ea typeface="+mn-ea"/>
+        <a:cs typeface="+mn-cs"/>
+      </a:defRPr>
+    </a:lvl6pPr>
+    <a:lvl7pPr marL="2743200" algn="l" defTabSz="457200" rtl="0" eaLnBrk="1" latinLnBrk="0" hangingPunct="1">
+      <a:defRPr sz="1200" kern="1200">
+        <a:solidFill>
+          <a:schemeClr val="tx1"/>
+        </a:solidFill>
+        <a:latin typeface="+mn-lt"/>
+        <a:ea typeface="+mn-ea"/>
+        <a:cs typeface="+mn-cs"/>
+      </a:defRPr>
+    </a:lvl7pPr>
+    <a:lvl8pPr marL="3200400" algn="l" defTabSz="457200" rtl="0" eaLnBrk="1" latinLnBrk="0" hangingPunct="1">
+      <a:defRPr sz="1200" kern="1200">
+        <a:solidFill>
+          <a:schemeClr val="tx1"/>
+        </a:solidFill>
+        <a:latin typeface="+mn-lt"/>
+        <a:ea typeface="+mn-ea"/>
+        <a:cs typeface="+mn-cs"/>
+      </a:defRPr>
+    </a:lvl8pPr>
+    <a:lvl9pPr marL="3657600" algn="l" defTabSz="457200" rtl="0" eaLnBrk="1" latinLnBrk="0" hangingPunct="1">
+      <a:defRPr sz="1200" kern="1200">
+        <a:solidFill>
+          <a:schemeClr val="tx1"/>
+        </a:solidFill>
+        <a:latin typeface="+mn-lt"/>
+        <a:ea typeface="+mn-ea"/>
+        <a:cs typeface="+mn-cs"/>
+      </a:defRPr>
+    </a:lvl9pPr>
+  </p:notesStyle>
+</p:notesMaster>
+</file>
+
+<file path=ppt/notesSlides/notesSlide1.xml><?xml version="1.0" encoding="utf-8"?>
+<p:notes xmlns:a="http://schemas.openxmlformats.org/drawingml/2006/main" xmlns:p="http://schemas.openxmlformats.org/presentationml/2006/main" xmlns:r="http://schemas.openxmlformats.org/officeDocument/2006/relationships">
+  <p:cSld>
+    <p:spTree>
+      <p:nvGrpSpPr>
+        <p:cNvPr id="1" name=""/>
+        <p:cNvGrpSpPr/>
+        <p:nvPr/>
+      </p:nvGrpSpPr>
+      <p:grpSpPr>
+        <a:xfrm>
+          <a:off x="0" y="0"/>
+          <a:ext cx="0" cy="0"/>
+          <a:chOff x="0" y="0"/>
+          <a:chExt cx="0" cy="0"/>
+        </a:xfrm>
+      </p:grpSpPr>
+      <p:sp>
+        <p:nvSpPr>
+          <p:cNvPr id="2" name="Slide Image Placeholder 1"/>
+          <p:cNvSpPr>
+            <a:spLocks noGrp="1"/>
+          </p:cNvSpPr>
+          <p:nvPr>
+            <p:ph type="sldImg" idx="2"/>
+          </p:nvPr>
+        </p:nvSpPr>
+        <p:spPr/>
+      </p:sp>
+      <p:sp>
+        <p:nvSpPr>
+          <p:cNvPr id="3" name="Notes Placeholder 2"/>
+          <p:cNvSpPr>
+            <a:spLocks noGrp="1"/>
+          </p:cNvSpPr>
+          <p:nvPr>
+            <p:ph type="body" idx="3" sz="quarter"/>
+          </p:nvPr>
+        </p:nvSpPr>
+        <p:spPr/>
+        <p:txBody>
+          <a:bodyPr/>
+          <a:lstStyle/>
+          <a:p>
+            <a:r>
+              <a:t>Hook: a good cup of West Lake Longjing depends on a few days of harvest window, and climate is disrupting it.</a:t>
+            </a:r>
+          </a:p>
+        </p:txBody>
+      </p:sp>
+      <p:sp>
+        <p:nvSpPr>
+          <p:cNvPr id="4" name="Slide Number Placeholder 3"/>
+          <p:cNvSpPr>
+            <a:spLocks noGrp="1"/>
+          </p:cNvSpPr>
+          <p:nvPr>
+            <p:ph type="sldNum" idx="5" sz="quarter"/>
+          </p:nvPr>
+        </p:nvSpPr>
+        <p:spPr/>
+      </p:sp>
+    </p:spTree>
+  </p:cSld>
+  <p:clrMapOvr>
+    <a:masterClrMapping/>
+  </p:clrMapOvr>
+</p:notes>
+</file>
+
+<file path=ppt/notesSlides/notesSlide10.xml><?xml version="1.0" encoding="utf-8"?>
+<p:notes xmlns:a="http://schemas.openxmlformats.org/drawingml/2006/main" xmlns:p="http://schemas.openxmlformats.org/presentationml/2006/main" xmlns:r="http://schemas.openxmlformats.org/officeDocument/2006/relationships">
+  <p:cSld>
+    <p:spTree>
+      <p:nvGrpSpPr>
+        <p:cNvPr id="1" name=""/>
+        <p:cNvGrpSpPr/>
+        <p:nvPr/>
+      </p:nvGrpSpPr>
+      <p:grpSpPr>
+        <a:xfrm>
+          <a:off x="0" y="0"/>
+          <a:ext cx="0" cy="0"/>
+          <a:chOff x="0" y="0"/>
+          <a:chExt cx="0" cy="0"/>
+        </a:xfrm>
+      </p:grpSpPr>
+      <p:sp>
+        <p:nvSpPr>
+          <p:cNvPr id="2" name="Slide Image Placeholder 1"/>
+          <p:cNvSpPr>
+            <a:spLocks noGrp="1"/>
+          </p:cNvSpPr>
+          <p:nvPr>
+            <p:ph type="sldImg" idx="2"/>
+          </p:nvPr>
+        </p:nvSpPr>
+        <p:spPr/>
+      </p:sp>
+      <p:sp>
+        <p:nvSpPr>
+          <p:cNvPr id="3" name="Notes Placeholder 2"/>
+          <p:cNvSpPr>
+            <a:spLocks noGrp="1"/>
+          </p:cNvSpPr>
+          <p:nvPr>
+            <p:ph type="body" idx="3" sz="quarter"/>
+          </p:nvPr>
+        </p:nvSpPr>
+        <p:spPr/>
+        <p:txBody>
+          <a:bodyPr/>
+          <a:lstStyle/>
+          <a:p>
+            <a:r>
+              <a:t>Close with the tagline and the three links (live/static/repo).</a:t>
+            </a:r>
+          </a:p>
+        </p:txBody>
+      </p:sp>
+      <p:sp>
+        <p:nvSpPr>
+          <p:cNvPr id="4" name="Slide Number Placeholder 3"/>
+          <p:cNvSpPr>
+            <a:spLocks noGrp="1"/>
+          </p:cNvSpPr>
+          <p:nvPr>
+            <p:ph type="sldNum" idx="5" sz="quarter"/>
+          </p:nvPr>
+        </p:nvSpPr>
+        <p:spPr/>
+      </p:sp>
+    </p:spTree>
+  </p:cSld>
+  <p:clrMapOvr>
+    <a:masterClrMapping/>
+  </p:clrMapOvr>
+</p:notes>
+</file>
+
+<file path=ppt/notesSlides/notesSlide2.xml><?xml version="1.0" encoding="utf-8"?>
+<p:notes xmlns:a="http://schemas.openxmlformats.org/drawingml/2006/main" xmlns:p="http://schemas.openxmlformats.org/presentationml/2006/main" xmlns:r="http://schemas.openxmlformats.org/officeDocument/2006/relationships">
+  <p:cSld>
+    <p:spTree>
+      <p:nvGrpSpPr>
+        <p:cNvPr id="1" name=""/>
+        <p:cNvGrpSpPr/>
+        <p:nvPr/>
+      </p:nvGrpSpPr>
+      <p:grpSpPr>
+        <a:xfrm>
+          <a:off x="0" y="0"/>
+          <a:ext cx="0" cy="0"/>
+          <a:chOff x="0" y="0"/>
+          <a:chExt cx="0" cy="0"/>
+        </a:xfrm>
+      </p:grpSpPr>
+      <p:sp>
+        <p:nvSpPr>
+          <p:cNvPr id="2" name="Slide Image Placeholder 1"/>
+          <p:cNvSpPr>
+            <a:spLocks noGrp="1"/>
+          </p:cNvSpPr>
+          <p:nvPr>
+            <p:ph type="sldImg" idx="2"/>
+          </p:nvPr>
+        </p:nvSpPr>
+        <p:spPr/>
+      </p:sp>
+      <p:sp>
+        <p:nvSpPr>
+          <p:cNvPr id="3" name="Notes Placeholder 2"/>
+          <p:cNvSpPr>
+            <a:spLocks noGrp="1"/>
+          </p:cNvSpPr>
+          <p:nvPr>
+            <p:ph type="body" idx="3" sz="quarter"/>
+          </p:nvPr>
+        </p:nvSpPr>
+        <p:spPr/>
+        <p:txBody>
+          <a:bodyPr/>
+          <a:lstStyle/>
+          <a:p>
+            <a:r>
+              <a:t>Evidence is public and citable: 2010 losses ~RMB 1.7bn; 2020/2022 ~5,000 mu heat damage; 2024 Hangzhou 60 high-temp days.</a:t>
+            </a:r>
+          </a:p>
+        </p:txBody>
+      </p:sp>
+      <p:sp>
+        <p:nvSpPr>
+          <p:cNvPr id="4" name="Slide Number Placeholder 3"/>
+          <p:cNvSpPr>
+            <a:spLocks noGrp="1"/>
+          </p:cNvSpPr>
+          <p:nvPr>
+            <p:ph type="sldNum" idx="5" sz="quarter"/>
+          </p:nvPr>
+        </p:nvSpPr>
+        <p:spPr/>
+      </p:sp>
+    </p:spTree>
+  </p:cSld>
+  <p:clrMapOvr>
+    <a:masterClrMapping/>
+  </p:clrMapOvr>
+</p:notes>
+</file>
+
+<file path=ppt/notesSlides/notesSlide3.xml><?xml version="1.0" encoding="utf-8"?>
+<p:notes xmlns:a="http://schemas.openxmlformats.org/drawingml/2006/main" xmlns:p="http://schemas.openxmlformats.org/presentationml/2006/main" xmlns:r="http://schemas.openxmlformats.org/officeDocument/2006/relationships">
+  <p:cSld>
+    <p:spTree>
+      <p:nvGrpSpPr>
+        <p:cNvPr id="1" name=""/>
+        <p:cNvGrpSpPr/>
+        <p:nvPr/>
+      </p:nvGrpSpPr>
+      <p:grpSpPr>
+        <a:xfrm>
+          <a:off x="0" y="0"/>
+          <a:ext cx="0" cy="0"/>
+          <a:chOff x="0" y="0"/>
+          <a:chExt cx="0" cy="0"/>
+        </a:xfrm>
+      </p:grpSpPr>
+      <p:sp>
+        <p:nvSpPr>
+          <p:cNvPr id="2" name="Slide Image Placeholder 1"/>
+          <p:cNvSpPr>
+            <a:spLocks noGrp="1"/>
+          </p:cNvSpPr>
+          <p:nvPr>
+            <p:ph type="sldImg" idx="2"/>
+          </p:nvPr>
+        </p:nvSpPr>
+        <p:spPr/>
+      </p:sp>
+      <p:sp>
+        <p:nvSpPr>
+          <p:cNvPr id="3" name="Notes Placeholder 2"/>
+          <p:cNvSpPr>
+            <a:spLocks noGrp="1"/>
+          </p:cNvSpPr>
+          <p:nvPr>
+            <p:ph type="body" idx="3" sz="quarter"/>
+          </p:nvPr>
+        </p:nvSpPr>
+        <p:spPr/>
+        <p:txBody>
+          <a:bodyPr/>
+          <a:lstStyle/>
+          <a:p>
+            <a:r>
+              <a:t>Three daily questions: risk today? which risk? harvest or protect? Signals are scattered; decision support only.</a:t>
+            </a:r>
+          </a:p>
+        </p:txBody>
+      </p:sp>
+      <p:sp>
+        <p:nvSpPr>
+          <p:cNvPr id="4" name="Slide Number Placeholder 3"/>
+          <p:cNvSpPr>
+            <a:spLocks noGrp="1"/>
+          </p:cNvSpPr>
+          <p:nvPr>
+            <p:ph type="sldNum" idx="5" sz="quarter"/>
+          </p:nvPr>
+        </p:nvSpPr>
+        <p:spPr/>
+      </p:sp>
+    </p:spTree>
+  </p:cSld>
+  <p:clrMapOvr>
+    <a:masterClrMapping/>
+  </p:clrMapOvr>
+</p:notes>
+</file>
+
+<file path=ppt/notesSlides/notesSlide4.xml><?xml version="1.0" encoding="utf-8"?>
+<p:notes xmlns:a="http://schemas.openxmlformats.org/drawingml/2006/main" xmlns:p="http://schemas.openxmlformats.org/presentationml/2006/main" xmlns:r="http://schemas.openxmlformats.org/officeDocument/2006/relationships">
+  <p:cSld>
+    <p:spTree>
+      <p:nvGrpSpPr>
+        <p:cNvPr id="1" name=""/>
+        <p:cNvGrpSpPr/>
+        <p:nvPr/>
+      </p:nvGrpSpPr>
+      <p:grpSpPr>
+        <a:xfrm>
+          <a:off x="0" y="0"/>
+          <a:ext cx="0" cy="0"/>
+          <a:chOff x="0" y="0"/>
+          <a:chExt cx="0" cy="0"/>
+        </a:xfrm>
+      </p:grpSpPr>
+      <p:sp>
+        <p:nvSpPr>
+          <p:cNvPr id="2" name="Slide Image Placeholder 1"/>
+          <p:cNvSpPr>
+            <a:spLocks noGrp="1"/>
+          </p:cNvSpPr>
+          <p:nvPr>
+            <p:ph type="sldImg" idx="2"/>
+          </p:nvPr>
+        </p:nvSpPr>
+        <p:spPr/>
+      </p:sp>
+      <p:sp>
+        <p:nvSpPr>
+          <p:cNvPr id="3" name="Notes Placeholder 2"/>
+          <p:cNvSpPr>
+            <a:spLocks noGrp="1"/>
+          </p:cNvSpPr>
+          <p:nvPr>
+            <p:ph type="body" idx="3" sz="quarter"/>
+          </p:nvPr>
+        </p:nvSpPr>
+        <p:spPr/>
+        <p:txBody>
+          <a:bodyPr/>
+          <a:lstStyle/>
+          <a:p>
+            <a:r>
+              <a:t>Dual-source weather (Open-Meteo history + MET Norway forecast with fallback), indicator engine, GBDT compound risk, transparent rules; LLM is optional rephrasing with rule fallback.</a:t>
+            </a:r>
+          </a:p>
+        </p:txBody>
+      </p:sp>
+      <p:sp>
+        <p:nvSpPr>
+          <p:cNvPr id="4" name="Slide Number Placeholder 3"/>
+          <p:cNvSpPr>
+            <a:spLocks noGrp="1"/>
+          </p:cNvSpPr>
+          <p:nvPr>
+            <p:ph type="sldNum" idx="5" sz="quarter"/>
+          </p:nvPr>
+        </p:nvSpPr>
+        <p:spPr/>
+      </p:sp>
+    </p:spTree>
+  </p:cSld>
+  <p:clrMapOvr>
+    <a:masterClrMapping/>
+  </p:clrMapOvr>
+</p:notes>
+</file>
+
+<file path=ppt/notesSlides/notesSlide5.xml><?xml version="1.0" encoding="utf-8"?>
+<p:notes xmlns:a="http://schemas.openxmlformats.org/drawingml/2006/main" xmlns:p="http://schemas.openxmlformats.org/presentationml/2006/main" xmlns:r="http://schemas.openxmlformats.org/officeDocument/2006/relationships">
+  <p:cSld>
+    <p:spTree>
+      <p:nvGrpSpPr>
+        <p:cNvPr id="1" name=""/>
+        <p:cNvGrpSpPr/>
+        <p:nvPr/>
+      </p:nvGrpSpPr>
+      <p:grpSpPr>
+        <a:xfrm>
+          <a:off x="0" y="0"/>
+          <a:ext cx="0" cy="0"/>
+          <a:chOff x="0" y="0"/>
+          <a:chExt cx="0" cy="0"/>
+        </a:xfrm>
+      </p:grpSpPr>
+      <p:sp>
+        <p:nvSpPr>
+          <p:cNvPr id="2" name="Slide Image Placeholder 1"/>
+          <p:cNvSpPr>
+            <a:spLocks noGrp="1"/>
+          </p:cNvSpPr>
+          <p:nvPr>
+            <p:ph type="sldImg" idx="2"/>
+          </p:nvPr>
+        </p:nvSpPr>
+        <p:spPr/>
+      </p:sp>
+      <p:sp>
+        <p:nvSpPr>
+          <p:cNvPr id="3" name="Notes Placeholder 2"/>
+          <p:cNvSpPr>
+            <a:spLocks noGrp="1"/>
+          </p:cNvSpPr>
+          <p:nvPr>
+            <p:ph type="body" idx="3" sz="quarter"/>
+          </p:nvPr>
+        </p:nvSpPr>
+        <p:spPr/>
+        <p:txBody>
+          <a:bodyPr/>
+          <a:lstStyle/>
+          <a:p>
+            <a:r>
+              <a:t>One threshold cannot capture frost x heat x drought x stage interactions. Held-out AUC 0.998/F1 0.85 vs 0.78/0.50; explicitly weak-label, not field accuracy.</a:t>
+            </a:r>
+          </a:p>
+        </p:txBody>
+      </p:sp>
+      <p:sp>
+        <p:nvSpPr>
+          <p:cNvPr id="4" name="Slide Number Placeholder 3"/>
+          <p:cNvSpPr>
+            <a:spLocks noGrp="1"/>
+          </p:cNvSpPr>
+          <p:nvPr>
+            <p:ph type="sldNum" idx="5" sz="quarter"/>
+          </p:nvPr>
+        </p:nvSpPr>
+        <p:spPr/>
+      </p:sp>
+    </p:spTree>
+  </p:cSld>
+  <p:clrMapOvr>
+    <a:masterClrMapping/>
+  </p:clrMapOvr>
+</p:notes>
+</file>
+
+<file path=ppt/notesSlides/notesSlide6.xml><?xml version="1.0" encoding="utf-8"?>
+<p:notes xmlns:a="http://schemas.openxmlformats.org/drawingml/2006/main" xmlns:p="http://schemas.openxmlformats.org/presentationml/2006/main" xmlns:r="http://schemas.openxmlformats.org/officeDocument/2006/relationships">
+  <p:cSld>
+    <p:spTree>
+      <p:nvGrpSpPr>
+        <p:cNvPr id="1" name=""/>
+        <p:cNvGrpSpPr/>
+        <p:nvPr/>
+      </p:nvGrpSpPr>
+      <p:grpSpPr>
+        <a:xfrm>
+          <a:off x="0" y="0"/>
+          <a:ext cx="0" cy="0"/>
+          <a:chOff x="0" y="0"/>
+          <a:chExt cx="0" cy="0"/>
+        </a:xfrm>
+      </p:grpSpPr>
+      <p:sp>
+        <p:nvSpPr>
+          <p:cNvPr id="2" name="Slide Image Placeholder 1"/>
+          <p:cNvSpPr>
+            <a:spLocks noGrp="1"/>
+          </p:cNvSpPr>
+          <p:nvPr>
+            <p:ph type="sldImg" idx="2"/>
+          </p:nvPr>
+        </p:nvSpPr>
+        <p:spPr/>
+      </p:sp>
+      <p:sp>
+        <p:nvSpPr>
+          <p:cNvPr id="3" name="Notes Placeholder 2"/>
+          <p:cNvSpPr>
+            <a:spLocks noGrp="1"/>
+          </p:cNvSpPr>
+          <p:nvPr>
+            <p:ph type="body" idx="3" sz="quarter"/>
+          </p:nvPr>
+        </p:nvSpPr>
+        <p:spPr/>
+        <p:txBody>
+          <a:bodyPr/>
+          <a:lstStyle/>
+          <a:p>
+            <a:r>
+              <a:t>From prediction to decisions: scheduling + expected utility (pick/wait/protect) + value/insurance + plot-level frost susceptibility.</a:t>
+            </a:r>
+          </a:p>
+        </p:txBody>
+      </p:sp>
+      <p:sp>
+        <p:nvSpPr>
+          <p:cNvPr id="4" name="Slide Number Placeholder 3"/>
+          <p:cNvSpPr>
+            <a:spLocks noGrp="1"/>
+          </p:cNvSpPr>
+          <p:nvPr>
+            <p:ph type="sldNum" idx="5" sz="quarter"/>
+          </p:nvPr>
+        </p:nvSpPr>
+        <p:spPr/>
+      </p:sp>
+    </p:spTree>
+  </p:cSld>
+  <p:clrMapOvr>
+    <a:masterClrMapping/>
+  </p:clrMapOvr>
+</p:notes>
+</file>
+
+<file path=ppt/notesSlides/notesSlide7.xml><?xml version="1.0" encoding="utf-8"?>
+<p:notes xmlns:a="http://schemas.openxmlformats.org/drawingml/2006/main" xmlns:p="http://schemas.openxmlformats.org/presentationml/2006/main" xmlns:r="http://schemas.openxmlformats.org/officeDocument/2006/relationships">
+  <p:cSld>
+    <p:spTree>
+      <p:nvGrpSpPr>
+        <p:cNvPr id="1" name=""/>
+        <p:cNvGrpSpPr/>
+        <p:nvPr/>
+      </p:nvGrpSpPr>
+      <p:grpSpPr>
+        <a:xfrm>
+          <a:off x="0" y="0"/>
+          <a:ext cx="0" cy="0"/>
+          <a:chOff x="0" y="0"/>
+          <a:chExt cx="0" cy="0"/>
+        </a:xfrm>
+      </p:grpSpPr>
+      <p:sp>
+        <p:nvSpPr>
+          <p:cNvPr id="2" name="Slide Image Placeholder 1"/>
+          <p:cNvSpPr>
+            <a:spLocks noGrp="1"/>
+          </p:cNvSpPr>
+          <p:nvPr>
+            <p:ph type="sldImg" idx="2"/>
+          </p:nvPr>
+        </p:nvSpPr>
+        <p:spPr/>
+      </p:sp>
+      <p:sp>
+        <p:nvSpPr>
+          <p:cNvPr id="3" name="Notes Placeholder 2"/>
+          <p:cNvSpPr>
+            <a:spLocks noGrp="1"/>
+          </p:cNvSpPr>
+          <p:nvPr>
+            <p:ph type="body" idx="3" sz="quarter"/>
+          </p:nvPr>
+        </p:nvSpPr>
+        <p:spPr/>
+        <p:txBody>
+          <a:bodyPr/>
+          <a:lstStyle/>
+          <a:p>
+            <a:r>
+              <a:t>Live demo: open the site, click In-house QA, ask a multi-part question, then show the QR share page.</a:t>
+            </a:r>
+          </a:p>
+        </p:txBody>
+      </p:sp>
+      <p:sp>
+        <p:nvSpPr>
+          <p:cNvPr id="4" name="Slide Number Placeholder 3"/>
+          <p:cNvSpPr>
+            <a:spLocks noGrp="1"/>
+          </p:cNvSpPr>
+          <p:nvPr>
+            <p:ph type="sldNum" idx="5" sz="quarter"/>
+          </p:nvPr>
+        </p:nvSpPr>
+        <p:spPr/>
+      </p:sp>
+    </p:spTree>
+  </p:cSld>
+  <p:clrMapOvr>
+    <a:masterClrMapping/>
+  </p:clrMapOvr>
+</p:notes>
+</file>
+
+<file path=ppt/notesSlides/notesSlide8.xml><?xml version="1.0" encoding="utf-8"?>
+<p:notes xmlns:a="http://schemas.openxmlformats.org/drawingml/2006/main" xmlns:p="http://schemas.openxmlformats.org/presentationml/2006/main" xmlns:r="http://schemas.openxmlformats.org/officeDocument/2006/relationships">
+  <p:cSld>
+    <p:spTree>
+      <p:nvGrpSpPr>
+        <p:cNvPr id="1" name=""/>
+        <p:cNvGrpSpPr/>
+        <p:nvPr/>
+      </p:nvGrpSpPr>
+      <p:grpSpPr>
+        <a:xfrm>
+          <a:off x="0" y="0"/>
+          <a:ext cx="0" cy="0"/>
+          <a:chOff x="0" y="0"/>
+          <a:chExt cx="0" cy="0"/>
+        </a:xfrm>
+      </p:grpSpPr>
+      <p:sp>
+        <p:nvSpPr>
+          <p:cNvPr id="2" name="Slide Image Placeholder 1"/>
+          <p:cNvSpPr>
+            <a:spLocks noGrp="1"/>
+          </p:cNvSpPr>
+          <p:nvPr>
+            <p:ph type="sldImg" idx="2"/>
+          </p:nvPr>
+        </p:nvSpPr>
+        <p:spPr/>
+      </p:sp>
+      <p:sp>
+        <p:nvSpPr>
+          <p:cNvPr id="3" name="Notes Placeholder 2"/>
+          <p:cNvSpPr>
+            <a:spLocks noGrp="1"/>
+          </p:cNvSpPr>
+          <p:nvPr>
+            <p:ph type="body" idx="3" sz="quarter"/>
+          </p:nvPr>
+        </p:nvSpPr>
+        <p:spPr/>
+        <p:txBody>
+          <a:bodyPr/>
+          <a:lstStyle/>
+          <a:p>
+            <a:r>
+              <a:t>Validation: 357-day spring frost MAE 1.32C vs 2.08C persistence; POD 0.709/FAR 0/CSI 0.709; 7/7 backtest. Next: frozen versions + plot sensors + field reports.</a:t>
+            </a:r>
+          </a:p>
+        </p:txBody>
+      </p:sp>
+      <p:sp>
+        <p:nvSpPr>
+          <p:cNvPr id="4" name="Slide Number Placeholder 3"/>
+          <p:cNvSpPr>
+            <a:spLocks noGrp="1"/>
+          </p:cNvSpPr>
+          <p:nvPr>
+            <p:ph type="sldNum" idx="5" sz="quarter"/>
+          </p:nvPr>
+        </p:nvSpPr>
+        <p:spPr/>
+      </p:sp>
+    </p:spTree>
+  </p:cSld>
+  <p:clrMapOvr>
+    <a:masterClrMapping/>
+  </p:clrMapOvr>
+</p:notes>
+</file>
+
+<file path=ppt/notesSlides/notesSlide9.xml><?xml version="1.0" encoding="utf-8"?>
+<p:notes xmlns:a="http://schemas.openxmlformats.org/drawingml/2006/main" xmlns:p="http://schemas.openxmlformats.org/presentationml/2006/main" xmlns:r="http://schemas.openxmlformats.org/officeDocument/2006/relationships">
+  <p:cSld>
+    <p:spTree>
+      <p:nvGrpSpPr>
+        <p:cNvPr id="1" name=""/>
+        <p:cNvGrpSpPr/>
+        <p:nvPr/>
+      </p:nvGrpSpPr>
+      <p:grpSpPr>
+        <a:xfrm>
+          <a:off x="0" y="0"/>
+          <a:ext cx="0" cy="0"/>
+          <a:chOff x="0" y="0"/>
+          <a:chExt cx="0" cy="0"/>
+        </a:xfrm>
+      </p:grpSpPr>
+      <p:sp>
+        <p:nvSpPr>
+          <p:cNvPr id="2" name="Slide Image Placeholder 1"/>
+          <p:cNvSpPr>
+            <a:spLocks noGrp="1"/>
+          </p:cNvSpPr>
+          <p:nvPr>
+            <p:ph type="sldImg" idx="2"/>
+          </p:nvPr>
+        </p:nvSpPr>
+        <p:spPr/>
+      </p:sp>
+      <p:sp>
+        <p:nvSpPr>
+          <p:cNvPr id="3" name="Notes Placeholder 2"/>
+          <p:cNvSpPr>
+            <a:spLocks noGrp="1"/>
+          </p:cNvSpPr>
+          <p:nvPr>
+            <p:ph type="body" idx="3" sz="quarter"/>
+          </p:nvPr>
+        </p:nvSpPr>
+        <p:spPr/>
+        <p:txBody>
+          <a:bodyPr/>
+          <a:lstStyle/>
+          <a:p>
+            <a:r>
+              <a:t>Run &amp; compliance: live/static forms; local uvicorn or offline single page; all data public and key-free; code MIT, data/docs CC BY 4.0.</a:t>
+            </a:r>
+          </a:p>
+        </p:txBody>
+      </p:sp>
+      <p:sp>
+        <p:nvSpPr>
+          <p:cNvPr id="4" name="Slide Number Placeholder 3"/>
+          <p:cNvSpPr>
+            <a:spLocks noGrp="1"/>
+          </p:cNvSpPr>
+          <p:nvPr>
+            <p:ph type="sldNum" idx="5" sz="quarter"/>
+          </p:nvPr>
+        </p:nvSpPr>
+        <p:spPr/>
+      </p:sp>
+    </p:spTree>
+  </p:cSld>
+  <p:clrMapOvr>
+    <a:masterClrMapping/>
+  </p:clrMapOvr>
+</p:notes>
 </file>
 
 <file path=ppt/slideLayouts/slideLayout1.xml><?xml version="1.0" encoding="utf-8"?>
@@ -3314,7 +4365,7 @@
 </p:sld>
 </file>
 
-<file path=ppt/slides/slide2.xml><?xml version="1.0" encoding="utf-8"?>
+<file path=ppt/slides/slide10.xml><?xml version="1.0" encoding="utf-8"?>
 <p:sld xmlns:a="http://schemas.openxmlformats.org/drawingml/2006/main" xmlns:p="http://schemas.openxmlformats.org/presentationml/2006/main" xmlns:r="http://schemas.openxmlformats.org/officeDocument/2006/relationships">
   <p:cSld>
     <p:spTree>
@@ -3418,6 +4469,234 @@
         </p:nvSpPr>
         <p:spPr>
           <a:xfrm>
+            <a:off x="822960" y="2011680"/>
+            <a:ext cx="10515600" cy="1463040"/>
+          </a:xfrm>
+          <a:prstGeom prst="rect">
+            <a:avLst/>
+          </a:prstGeom>
+          <a:noFill/>
+        </p:spPr>
+        <p:txBody>
+          <a:bodyPr wrap="none">
+            <a:spAutoFit/>
+          </a:bodyPr>
+          <a:lstStyle/>
+          <a:p>
+            <a:r>
+              <a:rPr sz="4000" b="1">
+                <a:solidFill>
+                  <a:srgbClr val="E8EEF3"/>
+                </a:solidFill>
+                <a:latin typeface="Segoe UI"/>
+              </a:rPr>
+              <a:t>ONE PLACE - ONE CLIMATE PROBLEM - ONE AI SOLUTION</a:t>
+            </a:r>
+          </a:p>
+        </p:txBody>
+      </p:sp>
+      <p:sp>
+        <p:nvSpPr>
+          <p:cNvPr id="5" name="TextBox 4"/>
+          <p:cNvSpPr txBox="1"/>
+          <p:nvPr/>
+        </p:nvSpPr>
+        <p:spPr>
+          <a:xfrm>
+            <a:off x="822960" y="3474720"/>
+            <a:ext cx="10515600" cy="640080"/>
+          </a:xfrm>
+          <a:prstGeom prst="rect">
+            <a:avLst/>
+          </a:prstGeom>
+          <a:noFill/>
+        </p:spPr>
+        <p:txBody>
+          <a:bodyPr wrap="none">
+            <a:spAutoFit/>
+          </a:bodyPr>
+          <a:lstStyle/>
+          <a:p>
+            <a:r>
+              <a:rPr sz="2000">
+                <a:solidFill>
+                  <a:srgbClr val="9FB4C6"/>
+                </a:solidFill>
+                <a:latin typeface="Segoe UI"/>
+              </a:rPr>
+              <a:t>TeaWindow - bringing AI to real tea gardens</a:t>
+            </a:r>
+          </a:p>
+        </p:txBody>
+      </p:sp>
+      <p:sp>
+        <p:nvSpPr>
+          <p:cNvPr id="6" name="TextBox 5"/>
+          <p:cNvSpPr txBox="1"/>
+          <p:nvPr/>
+        </p:nvSpPr>
+        <p:spPr>
+          <a:xfrm>
+            <a:off x="822960" y="4297680"/>
+            <a:ext cx="10515600" cy="1463040"/>
+          </a:xfrm>
+          <a:prstGeom prst="rect">
+            <a:avLst/>
+          </a:prstGeom>
+          <a:noFill/>
+        </p:spPr>
+        <p:txBody>
+          <a:bodyPr wrap="square">
+            <a:spAutoFit/>
+          </a:bodyPr>
+          <a:lstStyle/>
+          <a:p>
+            <a:r>
+              <a:rPr sz="1500">
+                <a:solidFill>
+                  <a:srgbClr val="9FB4C6"/>
+                </a:solidFill>
+                <a:latin typeface="Segoe UI"/>
+              </a:rPr>
+              <a:t>• Live https://teawindow.onrender.com/</a:t>
+            </a:r>
+          </a:p>
+          <a:p>
+            <a:r>
+              <a:rPr sz="1500">
+                <a:solidFill>
+                  <a:srgbClr val="9FB4C6"/>
+                </a:solidFill>
+                <a:latin typeface="Segoe UI"/>
+              </a:rPr>
+              <a:t>• Static https://eric2007-sudo.github.io/TeaWindow/</a:t>
+            </a:r>
+          </a:p>
+          <a:p>
+            <a:r>
+              <a:rPr sz="1500">
+                <a:solidFill>
+                  <a:srgbClr val="9FB4C6"/>
+                </a:solidFill>
+                <a:latin typeface="Segoe UI"/>
+              </a:rPr>
+              <a:t>• Repo https://github.com/Eric2007-sudo/TeaWindow</a:t>
+            </a:r>
+          </a:p>
+        </p:txBody>
+      </p:sp>
+    </p:spTree>
+  </p:cSld>
+  <p:clrMapOvr>
+    <a:masterClrMapping/>
+  </p:clrMapOvr>
+</p:sld>
+</file>
+
+<file path=ppt/slides/slide2.xml><?xml version="1.0" encoding="utf-8"?>
+<p:sld xmlns:a="http://schemas.openxmlformats.org/drawingml/2006/main" xmlns:p="http://schemas.openxmlformats.org/presentationml/2006/main" xmlns:r="http://schemas.openxmlformats.org/officeDocument/2006/relationships">
+  <p:cSld>
+    <p:spTree>
+      <p:nvGrpSpPr>
+        <p:cNvPr id="1" name=""/>
+        <p:cNvGrpSpPr/>
+        <p:nvPr/>
+      </p:nvGrpSpPr>
+      <p:grpSpPr/>
+      <p:sp>
+        <p:nvSpPr>
+          <p:cNvPr id="2" name="Rectangle 1"/>
+          <p:cNvSpPr/>
+          <p:nvPr/>
+        </p:nvSpPr>
+        <p:spPr>
+          <a:xfrm>
+            <a:off x="0" y="0"/>
+            <a:ext cx="12191695" cy="6858000"/>
+          </a:xfrm>
+          <a:prstGeom prst="rect">
+            <a:avLst/>
+          </a:prstGeom>
+          <a:solidFill>
+            <a:srgbClr val="0B1219"/>
+          </a:solidFill>
+          <a:ln>
+            <a:noFill/>
+          </a:ln>
+        </p:spPr>
+        <p:style>
+          <a:lnRef idx="1">
+            <a:schemeClr val="accent1"/>
+          </a:lnRef>
+          <a:fillRef idx="3">
+            <a:schemeClr val="accent1"/>
+          </a:fillRef>
+          <a:effectRef idx="2">
+            <a:schemeClr val="accent1"/>
+          </a:effectRef>
+          <a:fontRef idx="minor">
+            <a:schemeClr val="lt1"/>
+          </a:fontRef>
+        </p:style>
+        <p:txBody>
+          <a:bodyPr rtlCol="0" anchor="ctr"/>
+          <a:lstStyle/>
+          <a:p>
+            <a:pPr algn="ctr"/>
+          </a:p>
+        </p:txBody>
+      </p:sp>
+      <p:sp>
+        <p:nvSpPr>
+          <p:cNvPr id="3" name="Rectangle 2"/>
+          <p:cNvSpPr/>
+          <p:nvPr/>
+        </p:nvSpPr>
+        <p:spPr>
+          <a:xfrm>
+            <a:off x="0" y="0"/>
+            <a:ext cx="12191695" cy="109728"/>
+          </a:xfrm>
+          <a:prstGeom prst="rect">
+            <a:avLst/>
+          </a:prstGeom>
+          <a:solidFill>
+            <a:srgbClr val="4AA8FF"/>
+          </a:solidFill>
+          <a:ln>
+            <a:noFill/>
+          </a:ln>
+        </p:spPr>
+        <p:style>
+          <a:lnRef idx="1">
+            <a:schemeClr val="accent1"/>
+          </a:lnRef>
+          <a:fillRef idx="3">
+            <a:schemeClr val="accent1"/>
+          </a:fillRef>
+          <a:effectRef idx="2">
+            <a:schemeClr val="accent1"/>
+          </a:effectRef>
+          <a:fontRef idx="minor">
+            <a:schemeClr val="lt1"/>
+          </a:fontRef>
+        </p:style>
+        <p:txBody>
+          <a:bodyPr rtlCol="0" anchor="ctr"/>
+          <a:lstStyle/>
+          <a:p>
+            <a:pPr algn="ctr"/>
+          </a:p>
+        </p:txBody>
+      </p:sp>
+      <p:sp>
+        <p:nvSpPr>
+          <p:cNvPr id="4" name="TextBox 3"/>
+          <p:cNvSpPr txBox="1"/>
+          <p:nvPr/>
+        </p:nvSpPr>
+        <p:spPr>
+          <a:xfrm>
             <a:off x="640080" y="457200"/>
             <a:ext cx="10972800" cy="914400"/>
           </a:xfrm>
@@ -3524,7 +4803,7 @@
           <p:nvPr/>
         </p:nvPicPr>
         <p:blipFill>
-          <a:blip r:embed="rId2"/>
+          <a:blip r:embed="rId3"/>
           <a:stretch>
             <a:fillRect/>
           </a:stretch>
@@ -3998,7 +5277,7 @@
           <p:nvPr/>
         </p:nvPicPr>
         <p:blipFill>
-          <a:blip r:embed="rId2"/>
+          <a:blip r:embed="rId3"/>
           <a:stretch>
             <a:fillRect/>
           </a:stretch>
@@ -4247,7 +5526,7 @@
           <p:nvPr/>
         </p:nvPicPr>
         <p:blipFill>
-          <a:blip r:embed="rId2"/>
+          <a:blip r:embed="rId3"/>
           <a:stretch>
             <a:fillRect/>
           </a:stretch>
@@ -4480,7 +5759,7 @@
           <p:nvPr/>
         </p:nvPicPr>
         <p:blipFill>
-          <a:blip r:embed="rId2"/>
+          <a:blip r:embed="rId3"/>
           <a:stretch>
             <a:fillRect/>
           </a:stretch>
@@ -4729,7 +6008,7 @@
           <p:nvPr/>
         </p:nvPicPr>
         <p:blipFill>
-          <a:blip r:embed="rId2"/>
+          <a:blip r:embed="rId3"/>
           <a:stretch>
             <a:fillRect/>
           </a:stretch>
@@ -4978,7 +6257,7 @@
           <p:nvPr/>
         </p:nvPicPr>
         <p:blipFill>
-          <a:blip r:embed="rId2"/>
+          <a:blip r:embed="rId3"/>
           <a:stretch>
             <a:fillRect/>
           </a:stretch>
@@ -5105,8 +6384,8 @@
         </p:nvSpPr>
         <p:spPr>
           <a:xfrm>
-            <a:off x="822960" y="2011680"/>
-            <a:ext cx="10515600" cy="1463040"/>
+            <a:off x="640080" y="457200"/>
+            <a:ext cx="10972800" cy="914400"/>
           </a:xfrm>
           <a:prstGeom prst="rect">
             <a:avLst/>
@@ -5120,13 +6399,13 @@
           <a:lstStyle/>
           <a:p>
             <a:r>
-              <a:rPr sz="4000" b="1">
+              <a:rPr sz="2800" b="1">
                 <a:solidFill>
                   <a:srgbClr val="E8EEF3"/>
                 </a:solidFill>
                 <a:latin typeface="Segoe UI"/>
               </a:rPr>
-              <a:t>ONE PLACE - ONE CLIMATE PROBLEM - ONE AI SOLUTION</a:t>
+              <a:t>Run &amp; compliance</a:t>
             </a:r>
           </a:p>
         </p:txBody>
@@ -5139,8 +6418,8 @@
         </p:nvSpPr>
         <p:spPr>
           <a:xfrm>
-            <a:off x="822960" y="3474720"/>
-            <a:ext cx="10515600" cy="640080"/>
+            <a:off x="640080" y="1554480"/>
+            <a:ext cx="10789920" cy="4572000"/>
           </a:xfrm>
           <a:prstGeom prst="rect">
             <a:avLst/>
@@ -5148,75 +6427,72 @@
           <a:noFill/>
         </p:spPr>
         <p:txBody>
-          <a:bodyPr wrap="none">
+          <a:bodyPr wrap="square">
             <a:spAutoFit/>
           </a:bodyPr>
           <a:lstStyle/>
           <a:p>
-            <a:r>
-              <a:rPr sz="2000">
+            <a:pPr>
+              <a:spcAft>
+                <a:spcPts val="800"/>
+              </a:spcAft>
+            </a:pPr>
+            <a:r>
+              <a:rPr sz="1600">
                 <a:solidFill>
-                  <a:srgbClr val="9FB4C6"/>
+                  <a:srgbClr val="E8EEF3"/>
                 </a:solidFill>
                 <a:latin typeface="Segoe UI"/>
               </a:rPr>
-              <a:t>TeaWindow - bringing AI to real tea gardens</a:t>
-            </a:r>
-          </a:p>
-        </p:txBody>
-      </p:sp>
-      <p:sp>
-        <p:nvSpPr>
-          <p:cNvPr id="6" name="TextBox 5"/>
-          <p:cNvSpPr txBox="1"/>
-          <p:nvPr/>
-        </p:nvSpPr>
-        <p:spPr>
-          <a:xfrm>
-            <a:off x="822960" y="4297680"/>
-            <a:ext cx="10515600" cy="1463040"/>
-          </a:xfrm>
-          <a:prstGeom prst="rect">
-            <a:avLst/>
-          </a:prstGeom>
-          <a:noFill/>
-        </p:spPr>
-        <p:txBody>
-          <a:bodyPr wrap="square">
-            <a:spAutoFit/>
-          </a:bodyPr>
-          <a:lstStyle/>
-          <a:p>
-            <a:r>
-              <a:rPr sz="1500">
+              <a:t>• Live: https://teawindow.onrender.com/ ; Static: https://eric2007-sudo.github.io/TeaWindow/</a:t>
+            </a:r>
+          </a:p>
+          <a:p>
+            <a:pPr>
+              <a:spcAft>
+                <a:spcPts val="800"/>
+              </a:spcAft>
+            </a:pPr>
+            <a:r>
+              <a:rPr sz="1600">
                 <a:solidFill>
-                  <a:srgbClr val="9FB4C6"/>
+                  <a:srgbClr val="E8EEF3"/>
                 </a:solidFill>
                 <a:latin typeface="Segoe UI"/>
               </a:rPr>
-              <a:t>• Live https://teawindow.onrender.com/</a:t>
-            </a:r>
-          </a:p>
-          <a:p>
-            <a:r>
-              <a:rPr sz="1500">
+              <a:t>• Local: uvicorn src.serve:app ; Offline single-page: web/index.html</a:t>
+            </a:r>
+          </a:p>
+          <a:p>
+            <a:pPr>
+              <a:spcAft>
+                <a:spcPts val="800"/>
+              </a:spcAft>
+            </a:pPr>
+            <a:r>
+              <a:rPr sz="1600">
                 <a:solidFill>
-                  <a:srgbClr val="9FB4C6"/>
+                  <a:srgbClr val="E8EEF3"/>
                 </a:solidFill>
                 <a:latin typeface="Segoe UI"/>
               </a:rPr>
-              <a:t>• Static https://eric2007-sudo.github.io/TeaWindow/</a:t>
-            </a:r>
-          </a:p>
-          <a:p>
-            <a:r>
-              <a:rPr sz="1500">
+              <a:t>• Data: Open-Meteo ERA5 history + MET Norway forecast (dual-source), NASA GIBS NDVI, Sentinel-2, DEM</a:t>
+            </a:r>
+          </a:p>
+          <a:p>
+            <a:pPr>
+              <a:spcAft>
+                <a:spcPts val="800"/>
+              </a:spcAft>
+            </a:pPr>
+            <a:r>
+              <a:rPr sz="1600">
                 <a:solidFill>
-                  <a:srgbClr val="9FB4C6"/>
+                  <a:srgbClr val="E8EEF3"/>
                 </a:solidFill>
                 <a:latin typeface="Segoe UI"/>
               </a:rPr>
-              <a:t>• Repo https://github.com/Eric2007-sudo/TeaWindow</a:t>
+              <a:t>• License: code MIT, data/docs CC BY 4.0; decision support only</a:t>
             </a:r>
           </a:p>
         </p:txBody>
@@ -5547,4 +6823,324 @@
   </a:objectDefaults>
   <a:extraClrSchemeLst/>
 </a:theme>
+</file>
+
+<file path=ppt/theme/theme2.xml><?xml version="1.0" encoding="utf-8"?>
+<a:theme xmlns:a="http://schemas.openxmlformats.org/drawingml/2006/main" name="Office Theme">
+  <a:themeElements>
+    <a:clrScheme name="Office">
+      <a:dk1>
+        <a:sysClr val="windowText" lastClr="000000"/>
+      </a:dk1>
+      <a:lt1>
+        <a:sysClr val="window" lastClr="FFFFFF"/>
+      </a:lt1>
+      <a:dk2>
+        <a:srgbClr val="1F497D"/>
+      </a:dk2>
+      <a:lt2>
+        <a:srgbClr val="EEECE1"/>
+      </a:lt2>
+      <a:accent1>
+        <a:srgbClr val="4F81BD"/>
+      </a:accent1>
+      <a:accent2>
+        <a:srgbClr val="C0504D"/>
+      </a:accent2>
+      <a:accent3>
+        <a:srgbClr val="9BBB59"/>
+      </a:accent3>
+      <a:accent4>
+        <a:srgbClr val="8064A2"/>
+      </a:accent4>
+      <a:accent5>
+        <a:srgbClr val="4BACC6"/>
+      </a:accent5>
+      <a:accent6>
+        <a:srgbClr val="F79646"/>
+      </a:accent6>
+      <a:hlink>
+        <a:srgbClr val="0000FF"/>
+      </a:hlink>
+      <a:folHlink>
+        <a:srgbClr val="800080"/>
+      </a:folHlink>
+    </a:clrScheme>
+    <a:fontScheme name="Office">
+      <a:majorFont>
+        <a:latin typeface="Calibri"/>
+        <a:ea typeface=""/>
+        <a:cs typeface=""/>
+        <a:font script="Jpan" typeface="ＭＳ Ｐゴシック"/>
+        <a:font script="Hang" typeface="맑은 고딕"/>
+        <a:font script="Hans" typeface="宋体"/>
+        <a:font script="Hant" typeface="新細明體"/>
+        <a:font script="Arab" typeface="Times New Roman"/>
+        <a:font script="Hebr" typeface="Times New Roman"/>
+        <a:font script="Thai" typeface="Angsana New"/>
+        <a:font script="Ethi" typeface="Nyala"/>
+        <a:font script="Beng" typeface="Vrinda"/>
+        <a:font script="Gujr" typeface="Shruti"/>
+        <a:font script="Khmr" typeface="MoolBoran"/>
+        <a:font script="Knda" typeface="Tunga"/>
+        <a:font script="Guru" typeface="Raavi"/>
+        <a:font script="Cans" typeface="Euphemia"/>
+        <a:font script="Cher" typeface="Plantagenet Cherokee"/>
+        <a:font script="Yiii" typeface="Microsoft Yi Baiti"/>
+        <a:font script="Tibt" typeface="Microsoft Himalaya"/>
+        <a:font script="Thaa" typeface="MV Boli"/>
+        <a:font script="Deva" typeface="Mangal"/>
+        <a:font script="Telu" typeface="Gautami"/>
+        <a:font script="Taml" typeface="Latha"/>
+        <a:font script="Syrc" typeface="Estrangelo Edessa"/>
+        <a:font script="Orya" typeface="Kalinga"/>
+        <a:font script="Mlym" typeface="Kartika"/>
+        <a:font script="Laoo" typeface="DokChampa"/>
+        <a:font script="Sinh" typeface="Iskoola Pota"/>
+        <a:font script="Mong" typeface="Mongolian Baiti"/>
+        <a:font script="Viet" typeface="Times New Roman"/>
+        <a:font script="Uigh" typeface="Microsoft Uighur"/>
+        <a:font script="Geor" typeface="Sylfaen"/>
+      </a:majorFont>
+      <a:minorFont>
+        <a:latin typeface="Calibri"/>
+        <a:ea typeface=""/>
+        <a:cs typeface=""/>
+        <a:font script="Jpan" typeface="ＭＳ Ｐゴシック"/>
+        <a:font script="Hang" typeface="맑은 고딕"/>
+        <a:font script="Hans" typeface="宋体"/>
+        <a:font script="Hant" typeface="新細明體"/>
+        <a:font script="Arab" typeface="Arial"/>
+        <a:font script="Hebr" typeface="Arial"/>
+        <a:font script="Thai" typeface="Cordia New"/>
+        <a:font script="Ethi" typeface="Nyala"/>
+        <a:font script="Beng" typeface="Vrinda"/>
+        <a:font script="Gujr" typeface="Shruti"/>
+        <a:font script="Khmr" typeface="DaunPenh"/>
+        <a:font script="Knda" typeface="Tunga"/>
+        <a:font script="Guru" typeface="Raavi"/>
+        <a:font script="Cans" typeface="Euphemia"/>
+        <a:font script="Cher" typeface="Plantagenet Cherokee"/>
+        <a:font script="Yiii" typeface="Microsoft Yi Baiti"/>
+        <a:font script="Tibt" typeface="Microsoft Himalaya"/>
+        <a:font script="Thaa" typeface="MV Boli"/>
+        <a:font script="Deva" typeface="Mangal"/>
+        <a:font script="Telu" typeface="Gautami"/>
+        <a:font script="Taml" typeface="Latha"/>
+        <a:font script="Syrc" typeface="Estrangelo Edessa"/>
+        <a:font script="Orya" typeface="Kalinga"/>
+        <a:font script="Mlym" typeface="Kartika"/>
+        <a:font script="Laoo" typeface="DokChampa"/>
+        <a:font script="Sinh" typeface="Iskoola Pota"/>
+        <a:font script="Mong" typeface="Mongolian Baiti"/>
+        <a:font script="Viet" typeface="Arial"/>
+        <a:font script="Uigh" typeface="Microsoft Uighur"/>
+        <a:font script="Geor" typeface="Sylfaen"/>
+      </a:minorFont>
+    </a:fontScheme>
+    <a:fmtScheme name="Office">
+      <a:fillStyleLst>
+        <a:solidFill>
+          <a:schemeClr val="phClr"/>
+        </a:solidFill>
+        <a:gradFill rotWithShape="1">
+          <a:gsLst>
+            <a:gs pos="0">
+              <a:schemeClr val="phClr">
+                <a:tint val="50000"/>
+                <a:satMod val="300000"/>
+              </a:schemeClr>
+            </a:gs>
+            <a:gs pos="35000">
+              <a:schemeClr val="phClr">
+                <a:tint val="37000"/>
+                <a:satMod val="300000"/>
+              </a:schemeClr>
+            </a:gs>
+            <a:gs pos="100000">
+              <a:schemeClr val="phClr">
+                <a:tint val="15000"/>
+                <a:satMod val="350000"/>
+              </a:schemeClr>
+            </a:gs>
+          </a:gsLst>
+          <a:lin ang="16200000" scaled="1"/>
+        </a:gradFill>
+        <a:gradFill rotWithShape="1">
+          <a:gsLst>
+            <a:gs pos="0">
+              <a:schemeClr val="phClr">
+                <a:tint val="100000"/>
+                <a:shade val="100000"/>
+                <a:satMod val="130000"/>
+              </a:schemeClr>
+            </a:gs>
+            <a:gs pos="100000">
+              <a:schemeClr val="phClr">
+                <a:tint val="50000"/>
+                <a:shade val="100000"/>
+                <a:satMod val="350000"/>
+              </a:schemeClr>
+            </a:gs>
+          </a:gsLst>
+          <a:lin ang="16200000" scaled="0"/>
+        </a:gradFill>
+      </a:fillStyleLst>
+      <a:lnStyleLst>
+        <a:ln w="9525" cap="flat" cmpd="sng" algn="ctr">
+          <a:solidFill>
+            <a:schemeClr val="phClr">
+              <a:shade val="95000"/>
+              <a:satMod val="105000"/>
+            </a:schemeClr>
+          </a:solidFill>
+          <a:prstDash val="solid"/>
+        </a:ln>
+        <a:ln w="25400" cap="flat" cmpd="sng" algn="ctr">
+          <a:solidFill>
+            <a:schemeClr val="phClr"/>
+          </a:solidFill>
+          <a:prstDash val="solid"/>
+        </a:ln>
+        <a:ln w="38100" cap="flat" cmpd="sng" algn="ctr">
+          <a:solidFill>
+            <a:schemeClr val="phClr"/>
+          </a:solidFill>
+          <a:prstDash val="solid"/>
+        </a:ln>
+      </a:lnStyleLst>
+      <a:effectStyleLst>
+        <a:effectStyle>
+          <a:effectLst>
+            <a:outerShdw blurRad="40000" dist="20000" dir="5400000" rotWithShape="0">
+              <a:srgbClr val="000000">
+                <a:alpha val="38000"/>
+              </a:srgbClr>
+            </a:outerShdw>
+          </a:effectLst>
+        </a:effectStyle>
+        <a:effectStyle>
+          <a:effectLst>
+            <a:outerShdw blurRad="40000" dist="23000" dir="5400000" rotWithShape="0">
+              <a:srgbClr val="000000">
+                <a:alpha val="35000"/>
+              </a:srgbClr>
+            </a:outerShdw>
+          </a:effectLst>
+        </a:effectStyle>
+        <a:effectStyle>
+          <a:effectLst>
+            <a:outerShdw blurRad="40000" dist="23000" dir="5400000" rotWithShape="0">
+              <a:srgbClr val="000000">
+                <a:alpha val="35000"/>
+              </a:srgbClr>
+            </a:outerShdw>
+          </a:effectLst>
+          <a:scene3d>
+            <a:camera prst="orthographicFront">
+              <a:rot lat="0" lon="0" rev="0"/>
+            </a:camera>
+            <a:lightRig rig="threePt" dir="t">
+              <a:rot lat="0" lon="0" rev="1200000"/>
+            </a:lightRig>
+          </a:scene3d>
+          <a:sp3d>
+            <a:bevelT w="63500" h="25400"/>
+          </a:sp3d>
+        </a:effectStyle>
+      </a:effectStyleLst>
+      <a:bgFillStyleLst>
+        <a:solidFill>
+          <a:schemeClr val="phClr"/>
+        </a:solidFill>
+        <a:gradFill rotWithShape="1">
+          <a:gsLst>
+            <a:gs pos="0">
+              <a:schemeClr val="phClr">
+                <a:tint val="40000"/>
+                <a:satMod val="350000"/>
+              </a:schemeClr>
+            </a:gs>
+            <a:gs pos="40000">
+              <a:schemeClr val="phClr">
+                <a:tint val="45000"/>
+                <a:shade val="99000"/>
+                <a:satMod val="350000"/>
+              </a:schemeClr>
+            </a:gs>
+            <a:gs pos="100000">
+              <a:schemeClr val="phClr">
+                <a:shade val="20000"/>
+                <a:satMod val="255000"/>
+              </a:schemeClr>
+            </a:gs>
+          </a:gsLst>
+          <a:path path="circle">
+            <a:fillToRect l="50000" t="-80000" r="50000" b="180000"/>
+          </a:path>
+        </a:gradFill>
+        <a:gradFill rotWithShape="1">
+          <a:gsLst>
+            <a:gs pos="0">
+              <a:schemeClr val="phClr">
+                <a:tint val="80000"/>
+                <a:satMod val="300000"/>
+              </a:schemeClr>
+            </a:gs>
+            <a:gs pos="100000">
+              <a:schemeClr val="phClr">
+                <a:shade val="30000"/>
+                <a:satMod val="200000"/>
+              </a:schemeClr>
+            </a:gs>
+          </a:gsLst>
+          <a:path path="circle">
+            <a:fillToRect l="50000" t="50000" r="50000" b="50000"/>
+          </a:path>
+        </a:gradFill>
+      </a:bgFillStyleLst>
+    </a:fmtScheme>
+  </a:themeElements>
+  <a:objectDefaults>
+    <a:spDef>
+      <a:spPr/>
+      <a:bodyPr/>
+      <a:lstStyle/>
+      <a:style>
+        <a:lnRef idx="1">
+          <a:schemeClr val="accent1"/>
+        </a:lnRef>
+        <a:fillRef idx="3">
+          <a:schemeClr val="accent1"/>
+        </a:fillRef>
+        <a:effectRef idx="2">
+          <a:schemeClr val="accent1"/>
+        </a:effectRef>
+        <a:fontRef idx="minor">
+          <a:schemeClr val="lt1"/>
+        </a:fontRef>
+      </a:style>
+    </a:spDef>
+    <a:lnDef>
+      <a:spPr/>
+      <a:bodyPr/>
+      <a:lstStyle/>
+      <a:style>
+        <a:lnRef idx="2">
+          <a:schemeClr val="accent1"/>
+        </a:lnRef>
+        <a:fillRef idx="0">
+          <a:schemeClr val="accent1"/>
+        </a:fillRef>
+        <a:effectRef idx="1">
+          <a:schemeClr val="accent1"/>
+        </a:effectRef>
+        <a:fontRef idx="minor">
+          <a:schemeClr val="tx1"/>
+        </a:fontRef>
+      </a:style>
+    </a:lnDef>
+  </a:objectDefaults>
+  <a:extraClrSchemeLst/>
+</a:theme>
 </file>
</xml_diff>

<commit_message>
deck/video: add plot-level features + 3-step usage (12 slides, 60s video); update community post & checklist; refresh bundle
</commit_message>
<xml_diff>
--- a/submit/TeaWindow_Pitch_EN.pptx
+++ b/submit/TeaWindow_Pitch_EN.pptx
@@ -15,6 +15,8 @@
     <p:sldId id="263" r:id="rId15"/>
     <p:sldId id="264" r:id="rId16"/>
     <p:sldId id="265" r:id="rId17"/>
+    <p:sldId id="266" r:id="rId18"/>
+    <p:sldId id="267" r:id="rId19"/>
   </p:sldIdLst>
   <p:sldSz cx="12191695" cy="6858000" type="screen4x3"/>
   <p:notesSz cx="6858000" cy="9144000"/>
@@ -581,6 +583,146 @@
           <a:lstStyle/>
           <a:p>
             <a:r>
+              <a:t>Validation: 357-day spring frost MAE 1.32C vs 2.08C persistence; POD 0.709/FAR 0/CSI 0.709; 7/7 backtest. Next: frozen versions + plot sensors + field reports.</a:t>
+            </a:r>
+          </a:p>
+        </p:txBody>
+      </p:sp>
+      <p:sp>
+        <p:nvSpPr>
+          <p:cNvPr id="4" name="Slide Number Placeholder 3"/>
+          <p:cNvSpPr>
+            <a:spLocks noGrp="1"/>
+          </p:cNvSpPr>
+          <p:nvPr>
+            <p:ph type="sldNum" idx="5" sz="quarter"/>
+          </p:nvPr>
+        </p:nvSpPr>
+        <p:spPr/>
+      </p:sp>
+    </p:spTree>
+  </p:cSld>
+  <p:clrMapOvr>
+    <a:masterClrMapping/>
+  </p:clrMapOvr>
+</p:notes>
+</file>
+
+<file path=ppt/notesSlides/notesSlide11.xml><?xml version="1.0" encoding="utf-8"?>
+<p:notes xmlns:a="http://schemas.openxmlformats.org/drawingml/2006/main" xmlns:p="http://schemas.openxmlformats.org/presentationml/2006/main" xmlns:r="http://schemas.openxmlformats.org/officeDocument/2006/relationships">
+  <p:cSld>
+    <p:spTree>
+      <p:nvGrpSpPr>
+        <p:cNvPr id="1" name=""/>
+        <p:cNvGrpSpPr/>
+        <p:nvPr/>
+      </p:nvGrpSpPr>
+      <p:grpSpPr>
+        <a:xfrm>
+          <a:off x="0" y="0"/>
+          <a:ext cx="0" cy="0"/>
+          <a:chOff x="0" y="0"/>
+          <a:chExt cx="0" cy="0"/>
+        </a:xfrm>
+      </p:grpSpPr>
+      <p:sp>
+        <p:nvSpPr>
+          <p:cNvPr id="2" name="Slide Image Placeholder 1"/>
+          <p:cNvSpPr>
+            <a:spLocks noGrp="1"/>
+          </p:cNvSpPr>
+          <p:nvPr>
+            <p:ph type="sldImg" idx="2"/>
+          </p:nvPr>
+        </p:nvSpPr>
+        <p:spPr/>
+      </p:sp>
+      <p:sp>
+        <p:nvSpPr>
+          <p:cNvPr id="3" name="Notes Placeholder 2"/>
+          <p:cNvSpPr>
+            <a:spLocks noGrp="1"/>
+          </p:cNvSpPr>
+          <p:nvPr>
+            <p:ph type="body" idx="3" sz="quarter"/>
+          </p:nvPr>
+        </p:nvSpPr>
+        <p:spPr/>
+        <p:txBody>
+          <a:bodyPr/>
+          <a:lstStyle/>
+          <a:p>
+            <a:r>
+              <a:t>Run &amp; compliance: live/static forms; local uvicorn or offline single page; all data public and key-free; code MIT, data/docs CC BY 4.0.</a:t>
+            </a:r>
+          </a:p>
+        </p:txBody>
+      </p:sp>
+      <p:sp>
+        <p:nvSpPr>
+          <p:cNvPr id="4" name="Slide Number Placeholder 3"/>
+          <p:cNvSpPr>
+            <a:spLocks noGrp="1"/>
+          </p:cNvSpPr>
+          <p:nvPr>
+            <p:ph type="sldNum" idx="5" sz="quarter"/>
+          </p:nvPr>
+        </p:nvSpPr>
+        <p:spPr/>
+      </p:sp>
+    </p:spTree>
+  </p:cSld>
+  <p:clrMapOvr>
+    <a:masterClrMapping/>
+  </p:clrMapOvr>
+</p:notes>
+</file>
+
+<file path=ppt/notesSlides/notesSlide12.xml><?xml version="1.0" encoding="utf-8"?>
+<p:notes xmlns:a="http://schemas.openxmlformats.org/drawingml/2006/main" xmlns:p="http://schemas.openxmlformats.org/presentationml/2006/main" xmlns:r="http://schemas.openxmlformats.org/officeDocument/2006/relationships">
+  <p:cSld>
+    <p:spTree>
+      <p:nvGrpSpPr>
+        <p:cNvPr id="1" name=""/>
+        <p:cNvGrpSpPr/>
+        <p:nvPr/>
+      </p:nvGrpSpPr>
+      <p:grpSpPr>
+        <a:xfrm>
+          <a:off x="0" y="0"/>
+          <a:ext cx="0" cy="0"/>
+          <a:chOff x="0" y="0"/>
+          <a:chExt cx="0" cy="0"/>
+        </a:xfrm>
+      </p:grpSpPr>
+      <p:sp>
+        <p:nvSpPr>
+          <p:cNvPr id="2" name="Slide Image Placeholder 1"/>
+          <p:cNvSpPr>
+            <a:spLocks noGrp="1"/>
+          </p:cNvSpPr>
+          <p:nvPr>
+            <p:ph type="sldImg" idx="2"/>
+          </p:nvPr>
+        </p:nvSpPr>
+        <p:spPr/>
+      </p:sp>
+      <p:sp>
+        <p:nvSpPr>
+          <p:cNvPr id="3" name="Notes Placeholder 2"/>
+          <p:cNvSpPr>
+            <a:spLocks noGrp="1"/>
+          </p:cNvSpPr>
+          <p:nvPr>
+            <p:ph type="body" idx="3" sz="quarter"/>
+          </p:nvPr>
+        </p:nvSpPr>
+        <p:spPr/>
+        <p:txBody>
+          <a:bodyPr/>
+          <a:lstStyle/>
+          <a:p>
+            <a:r>
               <a:t>Close with the tagline and the three links (live/static/repo).</a:t>
             </a:r>
           </a:p>
@@ -1071,7 +1213,7 @@
           <a:lstStyle/>
           <a:p>
             <a:r>
-              <a:t>Validation: 357-day spring frost MAE 1.32C vs 2.08C persistence; POD 0.709/FAR 0/CSI 0.709; 7/7 backtest. Next: frozen versions + plot sensors + field reports.</a:t>
+              <a:t>Plot level: terrain risk map -&gt; click a spot -&gt; auto-generated plot data -&gt; printable health card; mention the multi-station sensor API.</a:t>
             </a:r>
           </a:p>
         </p:txBody>
@@ -1141,7 +1283,7 @@
           <a:lstStyle/>
           <a:p>
             <a:r>
-              <a:t>Run &amp; compliance: live/static forms; local uvicorn or offline single page; all data public and key-free; code MIT, data/docs CC BY 4.0.</a:t>
+              <a:t>Three steps: open the terrain map and pick a layer; click a spot to generate data; open the plot health card to print or ask for the next 3 days.</a:t>
             </a:r>
           </a:p>
         </p:txBody>
@@ -4469,6 +4611,480 @@
         </p:nvSpPr>
         <p:spPr>
           <a:xfrm>
+            <a:off x="640080" y="457200"/>
+            <a:ext cx="10972800" cy="914400"/>
+          </a:xfrm>
+          <a:prstGeom prst="rect">
+            <a:avLst/>
+          </a:prstGeom>
+          <a:noFill/>
+        </p:spPr>
+        <p:txBody>
+          <a:bodyPr wrap="none">
+            <a:spAutoFit/>
+          </a:bodyPr>
+          <a:lstStyle/>
+          <a:p>
+            <a:r>
+              <a:rPr sz="2800" b="1">
+                <a:solidFill>
+                  <a:srgbClr val="E8EEF3"/>
+                </a:solidFill>
+                <a:latin typeface="Segoe UI"/>
+              </a:rPr>
+              <a:t>Validation &amp; roadmap</a:t>
+            </a:r>
+          </a:p>
+        </p:txBody>
+      </p:sp>
+      <p:sp>
+        <p:nvSpPr>
+          <p:cNvPr id="5" name="TextBox 4"/>
+          <p:cNvSpPr txBox="1"/>
+          <p:nvPr/>
+        </p:nvSpPr>
+        <p:spPr>
+          <a:xfrm>
+            <a:off x="640080" y="1554480"/>
+            <a:ext cx="6035040" cy="4572000"/>
+          </a:xfrm>
+          <a:prstGeom prst="rect">
+            <a:avLst/>
+          </a:prstGeom>
+          <a:noFill/>
+        </p:spPr>
+        <p:txBody>
+          <a:bodyPr wrap="square">
+            <a:spAutoFit/>
+          </a:bodyPr>
+          <a:lstStyle/>
+          <a:p>
+            <a:pPr>
+              <a:spcAft>
+                <a:spcPts val="800"/>
+              </a:spcAft>
+            </a:pPr>
+            <a:r>
+              <a:rPr sz="1600">
+                <a:solidFill>
+                  <a:srgbClr val="E8EEF3"/>
+                </a:solidFill>
+                <a:latin typeface="Segoe UI"/>
+              </a:rPr>
+              <a:t>• Spring frost 357 days: Tmin MAE 1.32C (CI 1.21-1.43) vs 2.08C persistence</a:t>
+            </a:r>
+          </a:p>
+          <a:p>
+            <a:pPr>
+              <a:spcAft>
+                <a:spcPts val="800"/>
+              </a:spcAft>
+            </a:pPr>
+            <a:r>
+              <a:rPr sz="1600">
+                <a:solidFill>
+                  <a:srgbClr val="E8EEF3"/>
+                </a:solidFill>
+                <a:latin typeface="Segoe UI"/>
+              </a:rPr>
+              <a:t>• 1/3/7-day MAE 0.49/0.67/0.91C; POD 0.709 / FAR 0 / CSI 0.709</a:t>
+            </a:r>
+          </a:p>
+          <a:p>
+            <a:pPr>
+              <a:spcAft>
+                <a:spcPts val="800"/>
+              </a:spcAft>
+            </a:pPr>
+            <a:r>
+              <a:rPr sz="1600">
+                <a:solidFill>
+                  <a:srgbClr val="E8EEF3"/>
+                </a:solidFill>
+                <a:latin typeface="Segoe UI"/>
+              </a:rPr>
+              <a:t>• Event backtest 7/7; next: frozen versions + plot sensors + positive/negative field reports</a:t>
+            </a:r>
+          </a:p>
+          <a:p>
+            <a:pPr>
+              <a:spcAft>
+                <a:spcPts val="800"/>
+              </a:spcAft>
+            </a:pPr>
+            <a:r>
+              <a:rPr sz="1600">
+                <a:solidFill>
+                  <a:srgbClr val="E8EEF3"/>
+                </a:solidFill>
+                <a:latin typeface="Segoe UI"/>
+              </a:rPr>
+              <a:t>• 90-day field pilot; decision support only</a:t>
+            </a:r>
+          </a:p>
+        </p:txBody>
+      </p:sp>
+      <p:pic>
+        <p:nvPicPr>
+          <p:cNvPr id="6" name="Picture 5" descr="fig_backtest.png"/>
+          <p:cNvPicPr>
+            <a:picLocks noChangeAspect="1"/>
+          </p:cNvPicPr>
+          <p:nvPr/>
+        </p:nvPicPr>
+        <p:blipFill>
+          <a:blip r:embed="rId3"/>
+          <a:stretch>
+            <a:fillRect/>
+          </a:stretch>
+        </p:blipFill>
+        <p:spPr>
+          <a:xfrm>
+            <a:off x="6858000" y="1645920"/>
+            <a:ext cx="4358640" cy="4023360"/>
+          </a:xfrm>
+          <a:prstGeom prst="rect">
+            <a:avLst/>
+          </a:prstGeom>
+        </p:spPr>
+      </p:pic>
+    </p:spTree>
+  </p:cSld>
+  <p:clrMapOvr>
+    <a:masterClrMapping/>
+  </p:clrMapOvr>
+</p:sld>
+</file>
+
+<file path=ppt/slides/slide11.xml><?xml version="1.0" encoding="utf-8"?>
+<p:sld xmlns:a="http://schemas.openxmlformats.org/drawingml/2006/main" xmlns:p="http://schemas.openxmlformats.org/presentationml/2006/main" xmlns:r="http://schemas.openxmlformats.org/officeDocument/2006/relationships">
+  <p:cSld>
+    <p:spTree>
+      <p:nvGrpSpPr>
+        <p:cNvPr id="1" name=""/>
+        <p:cNvGrpSpPr/>
+        <p:nvPr/>
+      </p:nvGrpSpPr>
+      <p:grpSpPr/>
+      <p:sp>
+        <p:nvSpPr>
+          <p:cNvPr id="2" name="Rectangle 1"/>
+          <p:cNvSpPr/>
+          <p:nvPr/>
+        </p:nvSpPr>
+        <p:spPr>
+          <a:xfrm>
+            <a:off x="0" y="0"/>
+            <a:ext cx="12191695" cy="6858000"/>
+          </a:xfrm>
+          <a:prstGeom prst="rect">
+            <a:avLst/>
+          </a:prstGeom>
+          <a:solidFill>
+            <a:srgbClr val="0B1219"/>
+          </a:solidFill>
+          <a:ln>
+            <a:noFill/>
+          </a:ln>
+        </p:spPr>
+        <p:style>
+          <a:lnRef idx="1">
+            <a:schemeClr val="accent1"/>
+          </a:lnRef>
+          <a:fillRef idx="3">
+            <a:schemeClr val="accent1"/>
+          </a:fillRef>
+          <a:effectRef idx="2">
+            <a:schemeClr val="accent1"/>
+          </a:effectRef>
+          <a:fontRef idx="minor">
+            <a:schemeClr val="lt1"/>
+          </a:fontRef>
+        </p:style>
+        <p:txBody>
+          <a:bodyPr rtlCol="0" anchor="ctr"/>
+          <a:lstStyle/>
+          <a:p>
+            <a:pPr algn="ctr"/>
+          </a:p>
+        </p:txBody>
+      </p:sp>
+      <p:sp>
+        <p:nvSpPr>
+          <p:cNvPr id="3" name="Rectangle 2"/>
+          <p:cNvSpPr/>
+          <p:nvPr/>
+        </p:nvSpPr>
+        <p:spPr>
+          <a:xfrm>
+            <a:off x="0" y="0"/>
+            <a:ext cx="12191695" cy="109728"/>
+          </a:xfrm>
+          <a:prstGeom prst="rect">
+            <a:avLst/>
+          </a:prstGeom>
+          <a:solidFill>
+            <a:srgbClr val="4AA8FF"/>
+          </a:solidFill>
+          <a:ln>
+            <a:noFill/>
+          </a:ln>
+        </p:spPr>
+        <p:style>
+          <a:lnRef idx="1">
+            <a:schemeClr val="accent1"/>
+          </a:lnRef>
+          <a:fillRef idx="3">
+            <a:schemeClr val="accent1"/>
+          </a:fillRef>
+          <a:effectRef idx="2">
+            <a:schemeClr val="accent1"/>
+          </a:effectRef>
+          <a:fontRef idx="minor">
+            <a:schemeClr val="lt1"/>
+          </a:fontRef>
+        </p:style>
+        <p:txBody>
+          <a:bodyPr rtlCol="0" anchor="ctr"/>
+          <a:lstStyle/>
+          <a:p>
+            <a:pPr algn="ctr"/>
+          </a:p>
+        </p:txBody>
+      </p:sp>
+      <p:sp>
+        <p:nvSpPr>
+          <p:cNvPr id="4" name="TextBox 3"/>
+          <p:cNvSpPr txBox="1"/>
+          <p:nvPr/>
+        </p:nvSpPr>
+        <p:spPr>
+          <a:xfrm>
+            <a:off x="640080" y="457200"/>
+            <a:ext cx="10972800" cy="914400"/>
+          </a:xfrm>
+          <a:prstGeom prst="rect">
+            <a:avLst/>
+          </a:prstGeom>
+          <a:noFill/>
+        </p:spPr>
+        <p:txBody>
+          <a:bodyPr wrap="none">
+            <a:spAutoFit/>
+          </a:bodyPr>
+          <a:lstStyle/>
+          <a:p>
+            <a:r>
+              <a:rPr sz="2800" b="1">
+                <a:solidFill>
+                  <a:srgbClr val="E8EEF3"/>
+                </a:solidFill>
+                <a:latin typeface="Segoe UI"/>
+              </a:rPr>
+              <a:t>Run &amp; compliance</a:t>
+            </a:r>
+          </a:p>
+        </p:txBody>
+      </p:sp>
+      <p:sp>
+        <p:nvSpPr>
+          <p:cNvPr id="5" name="TextBox 4"/>
+          <p:cNvSpPr txBox="1"/>
+          <p:nvPr/>
+        </p:nvSpPr>
+        <p:spPr>
+          <a:xfrm>
+            <a:off x="640080" y="1554480"/>
+            <a:ext cx="10789920" cy="4572000"/>
+          </a:xfrm>
+          <a:prstGeom prst="rect">
+            <a:avLst/>
+          </a:prstGeom>
+          <a:noFill/>
+        </p:spPr>
+        <p:txBody>
+          <a:bodyPr wrap="square">
+            <a:spAutoFit/>
+          </a:bodyPr>
+          <a:lstStyle/>
+          <a:p>
+            <a:pPr>
+              <a:spcAft>
+                <a:spcPts val="800"/>
+              </a:spcAft>
+            </a:pPr>
+            <a:r>
+              <a:rPr sz="1600">
+                <a:solidFill>
+                  <a:srgbClr val="E8EEF3"/>
+                </a:solidFill>
+                <a:latin typeface="Segoe UI"/>
+              </a:rPr>
+              <a:t>• Live: https://teawindow.onrender.com/ ; Static: https://eric2007-sudo.github.io/TeaWindow/</a:t>
+            </a:r>
+          </a:p>
+          <a:p>
+            <a:pPr>
+              <a:spcAft>
+                <a:spcPts val="800"/>
+              </a:spcAft>
+            </a:pPr>
+            <a:r>
+              <a:rPr sz="1600">
+                <a:solidFill>
+                  <a:srgbClr val="E8EEF3"/>
+                </a:solidFill>
+                <a:latin typeface="Segoe UI"/>
+              </a:rPr>
+              <a:t>• Local: uvicorn src.serve:app ; Offline single-page: web/index.html</a:t>
+            </a:r>
+          </a:p>
+          <a:p>
+            <a:pPr>
+              <a:spcAft>
+                <a:spcPts val="800"/>
+              </a:spcAft>
+            </a:pPr>
+            <a:r>
+              <a:rPr sz="1600">
+                <a:solidFill>
+                  <a:srgbClr val="E8EEF3"/>
+                </a:solidFill>
+                <a:latin typeface="Segoe UI"/>
+              </a:rPr>
+              <a:t>• Data: Open-Meteo ERA5 history + MET Norway forecast (dual-source), NASA GIBS NDVI, Sentinel-2, DEM</a:t>
+            </a:r>
+          </a:p>
+          <a:p>
+            <a:pPr>
+              <a:spcAft>
+                <a:spcPts val="800"/>
+              </a:spcAft>
+            </a:pPr>
+            <a:r>
+              <a:rPr sz="1600">
+                <a:solidFill>
+                  <a:srgbClr val="E8EEF3"/>
+                </a:solidFill>
+                <a:latin typeface="Segoe UI"/>
+              </a:rPr>
+              <a:t>• License: code MIT, data/docs CC BY 4.0; decision support only</a:t>
+            </a:r>
+          </a:p>
+        </p:txBody>
+      </p:sp>
+    </p:spTree>
+  </p:cSld>
+  <p:clrMapOvr>
+    <a:masterClrMapping/>
+  </p:clrMapOvr>
+</p:sld>
+</file>
+
+<file path=ppt/slides/slide12.xml><?xml version="1.0" encoding="utf-8"?>
+<p:sld xmlns:a="http://schemas.openxmlformats.org/drawingml/2006/main" xmlns:p="http://schemas.openxmlformats.org/presentationml/2006/main" xmlns:r="http://schemas.openxmlformats.org/officeDocument/2006/relationships">
+  <p:cSld>
+    <p:spTree>
+      <p:nvGrpSpPr>
+        <p:cNvPr id="1" name=""/>
+        <p:cNvGrpSpPr/>
+        <p:nvPr/>
+      </p:nvGrpSpPr>
+      <p:grpSpPr/>
+      <p:sp>
+        <p:nvSpPr>
+          <p:cNvPr id="2" name="Rectangle 1"/>
+          <p:cNvSpPr/>
+          <p:nvPr/>
+        </p:nvSpPr>
+        <p:spPr>
+          <a:xfrm>
+            <a:off x="0" y="0"/>
+            <a:ext cx="12191695" cy="6858000"/>
+          </a:xfrm>
+          <a:prstGeom prst="rect">
+            <a:avLst/>
+          </a:prstGeom>
+          <a:solidFill>
+            <a:srgbClr val="0B1219"/>
+          </a:solidFill>
+          <a:ln>
+            <a:noFill/>
+          </a:ln>
+        </p:spPr>
+        <p:style>
+          <a:lnRef idx="1">
+            <a:schemeClr val="accent1"/>
+          </a:lnRef>
+          <a:fillRef idx="3">
+            <a:schemeClr val="accent1"/>
+          </a:fillRef>
+          <a:effectRef idx="2">
+            <a:schemeClr val="accent1"/>
+          </a:effectRef>
+          <a:fontRef idx="minor">
+            <a:schemeClr val="lt1"/>
+          </a:fontRef>
+        </p:style>
+        <p:txBody>
+          <a:bodyPr rtlCol="0" anchor="ctr"/>
+          <a:lstStyle/>
+          <a:p>
+            <a:pPr algn="ctr"/>
+          </a:p>
+        </p:txBody>
+      </p:sp>
+      <p:sp>
+        <p:nvSpPr>
+          <p:cNvPr id="3" name="Rectangle 2"/>
+          <p:cNvSpPr/>
+          <p:nvPr/>
+        </p:nvSpPr>
+        <p:spPr>
+          <a:xfrm>
+            <a:off x="0" y="0"/>
+            <a:ext cx="12191695" cy="109728"/>
+          </a:xfrm>
+          <a:prstGeom prst="rect">
+            <a:avLst/>
+          </a:prstGeom>
+          <a:solidFill>
+            <a:srgbClr val="4AA8FF"/>
+          </a:solidFill>
+          <a:ln>
+            <a:noFill/>
+          </a:ln>
+        </p:spPr>
+        <p:style>
+          <a:lnRef idx="1">
+            <a:schemeClr val="accent1"/>
+          </a:lnRef>
+          <a:fillRef idx="3">
+            <a:schemeClr val="accent1"/>
+          </a:fillRef>
+          <a:effectRef idx="2">
+            <a:schemeClr val="accent1"/>
+          </a:effectRef>
+          <a:fontRef idx="minor">
+            <a:schemeClr val="lt1"/>
+          </a:fontRef>
+        </p:style>
+        <p:txBody>
+          <a:bodyPr rtlCol="0" anchor="ctr"/>
+          <a:lstStyle/>
+          <a:p>
+            <a:pPr algn="ctr"/>
+          </a:p>
+        </p:txBody>
+      </p:sp>
+      <p:sp>
+        <p:nvSpPr>
+          <p:cNvPr id="4" name="TextBox 3"/>
+          <p:cNvSpPr txBox="1"/>
+          <p:nvPr/>
+        </p:nvSpPr>
+        <p:spPr>
+          <a:xfrm>
             <a:off x="822960" y="2011680"/>
             <a:ext cx="10515600" cy="1463040"/>
           </a:xfrm>
@@ -6156,7 +6772,7 @@
                 </a:solidFill>
                 <a:latin typeface="Segoe UI"/>
               </a:rPr>
-              <a:t>Validation &amp; roadmap</a:t>
+              <a:t>Plot-level: what's new</a:t>
             </a:r>
           </a:p>
         </p:txBody>
@@ -6170,7 +6786,7 @@
         <p:spPr>
           <a:xfrm>
             <a:off x="640080" y="1554480"/>
-            <a:ext cx="6035040" cy="4572000"/>
+            <a:ext cx="10789920" cy="4572000"/>
           </a:xfrm>
           <a:prstGeom prst="rect">
             <a:avLst/>
@@ -6195,7 +6811,7 @@
                 </a:solidFill>
                 <a:latin typeface="Segoe UI"/>
               </a:rPr>
-              <a:t>• Spring frost 357 days: Tmin MAE 1.32C (CI 1.21-1.43) vs 2.08C persistence</a:t>
+              <a:t>• 1) Terrain risk map: DEM hillshade + contours/scale/north arrow; live layers (composite/frost/heat/drought, 60s)</a:t>
             </a:r>
           </a:p>
           <a:p>
@@ -6211,7 +6827,7 @@
                 </a:solidFill>
                 <a:latin typeface="Segoe UI"/>
               </a:rPr>
-              <a:t>• 1/3/7-day MAE 0.49/0.67/0.91C; POD 0.709 / FAR 0 / CSI 0.709</a:t>
+              <a:t>• 2) Click-to-data: any spot -&gt; elevation/slope/aspect + downscaled Tmin/Tmax + risk R + advice</a:t>
             </a:r>
           </a:p>
           <a:p>
@@ -6227,7 +6843,7 @@
                 </a:solidFill>
                 <a:latin typeface="Segoe UI"/>
               </a:rPr>
-              <a:t>• Event backtest 7/7; next: frozen versions + plot sensors + positive/negative field reports</a:t>
+              <a:t>• 3) Printable plot health card: today + 3-day outlook + provenance (save as PDF)</a:t>
             </a:r>
           </a:p>
           <a:p>
@@ -6243,35 +6859,27 @@
                 </a:solidFill>
                 <a:latin typeface="Segoe UI"/>
               </a:rPr>
-              <a:t>• 90-day field pilot; decision support only</a:t>
-            </a:r>
-          </a:p>
-        </p:txBody>
-      </p:sp>
-      <p:pic>
-        <p:nvPicPr>
-          <p:cNvPr id="6" name="Picture 5" descr="fig_backtest.png"/>
-          <p:cNvPicPr>
-            <a:picLocks noChangeAspect="1"/>
-          </p:cNvPicPr>
-          <p:nvPr/>
-        </p:nvPicPr>
-        <p:blipFill>
-          <a:blip r:embed="rId3"/>
-          <a:stretch>
-            <a:fillRect/>
-          </a:stretch>
-        </p:blipFill>
-        <p:spPr>
-          <a:xfrm>
-            <a:off x="6858000" y="1645920"/>
-            <a:ext cx="4358640" cy="4023360"/>
-          </a:xfrm>
-          <a:prstGeom prst="rect">
-            <a:avLst/>
-          </a:prstGeom>
-        </p:spPr>
-      </p:pic>
+              <a:t>• 4) Multi-day plot Q&amp;A: 'how to manage this plot for the next N days' -&gt; daily Tmin/Tmax/rain/R</a:t>
+            </a:r>
+          </a:p>
+          <a:p>
+            <a:pPr>
+              <a:spcAft>
+                <a:spcPts val="800"/>
+              </a:spcAft>
+            </a:pPr>
+            <a:r>
+              <a:rPr sz="1600">
+                <a:solidFill>
+                  <a:srgbClr val="E8EEF3"/>
+                </a:solidFill>
+                <a:latin typeface="Segoe UI"/>
+              </a:rPr>
+              <a:t>• 5) Multi-station sensors: register any station_id + plot coordinates; markers on the map</a:t>
+            </a:r>
+          </a:p>
+        </p:txBody>
+      </p:sp>
     </p:spTree>
   </p:cSld>
   <p:clrMapOvr>
@@ -6405,7 +7013,7 @@
                 </a:solidFill>
                 <a:latin typeface="Segoe UI"/>
               </a:rPr>
-              <a:t>Run &amp; compliance</a:t>
+              <a:t>How to use: 3 steps</a:t>
             </a:r>
           </a:p>
         </p:txBody>
@@ -6444,7 +7052,7 @@
                 </a:solidFill>
                 <a:latin typeface="Segoe UI"/>
               </a:rPr>
-              <a:t>• Live: https://teawindow.onrender.com/ ; Static: https://eric2007-sudo.github.io/TeaWindow/</a:t>
+              <a:t>• Step 1 Open the terrain risk map and pick a layer (composite/frost/heat/drought)</a:t>
             </a:r>
           </a:p>
           <a:p>
@@ -6460,7 +7068,7 @@
                 </a:solidFill>
                 <a:latin typeface="Segoe UI"/>
               </a:rPr>
-              <a:t>• Local: uvicorn src.serve:app ; Offline single-page: web/index.html</a:t>
+              <a:t>• Step 2 Click any spot: plot data is generated automatically (elevation/aspect/downscaled Tmin-Tmax/risk R/advice)</a:t>
             </a:r>
           </a:p>
           <a:p>
@@ -6476,7 +7084,7 @@
                 </a:solidFill>
                 <a:latin typeface="Segoe UI"/>
               </a:rPr>
-              <a:t>• Data: Open-Meteo ERA5 history + MET Norway forecast (dual-source), NASA GIBS NDVI, Sentinel-2, DEM</a:t>
+              <a:t>• Step 3 Ask or export: 'how to manage this plot for 3 days', or open the plot health card to print</a:t>
             </a:r>
           </a:p>
           <a:p>
@@ -6492,7 +7100,7 @@
                 </a:solidFill>
                 <a:latin typeface="Segoe UI"/>
               </a:rPr>
-              <a:t>• License: code MIT, data/docs CC BY 4.0; decision support only</a:t>
+              <a:t>• Links: /terrain.html | plot card: /plot_report.html?lat=30.2215&amp;lon=120.1000</a:t>
             </a:r>
           </a:p>
         </p:txBody>

</xml_diff>